<commit_message>
Recalibrate 2027 budget pitch with 2026 execution data
Co-Authored-By: Claude Opus 5.5 <noreply@anthropic.com>
Claude-Session: https://claude.ai/code/session_011mVvDzVJqJWuqDhVDGwPKG
</commit_message>
<xml_diff>
--- a/reports/GLT_Budget_Marketing_2027.pptx
+++ b/reports/GLT_Budget_Marketing_2027.pptx
@@ -109,17 +109,17 @@
   <p:extLst>
     <p:ext uri="{521415D9-36F7-43E2-AB2F-B90AF26B5E84}">
       <p14:sectionLst xmlns:p14="http://schemas.microsoft.com/office/powerpoint/2010/main">
-        <p14:section name="Diagnóstico" id="{ae91621f-54ab-9d0d-6cef-9a63cf27aa9a}">
+        <p14:section name="Resultados 2026" id="{721b4bfd-d695-663d-ae09-3a52d486643d}">
           <p14:sldIdLst>
             <p14:sldId id="256"/>
           </p14:sldIdLst>
         </p14:section>
-        <p14:section name="Presupuesto" id="{c21a2166-6866-4e97-b034-a6839866d8d7}">
+        <p14:section name="Presupuesto 2027" id="{74981d6d-0172-9c38-c6f1-d3e22f32737a}">
           <p14:sldIdLst>
             <p14:sldId id="257"/>
           </p14:sldIdLst>
         </p14:section>
-        <p14:section name="Decisión" id="{7ab6662c-99dd-4af4-c236-3afcf6c61956}">
+        <p14:section name="Metas 2027" id="{f8576777-8ecb-b9ef-16bc-77edb98d6e85}">
           <p14:sldIdLst>
             <p14:sldId id="258"/>
           </p14:sldIdLst>
@@ -159,7 +159,7 @@
                 </a:solidFill>
                 <a:latin typeface="+mn-lt"/>
               </a:rPr>
-              <a:t>Citas como fuente en respuestas de IA (Google, EE. UU.)</a:t>
+              <a:t>Embudo 2026 por canal</a:t>
             </a:r>
           </a:p>
         </c:rich>
@@ -171,7 +171,7 @@
     <c:plotArea>
       <c:layout/>
       <c:barChart>
-        <c:barDir val="bar"/>
+        <c:barDir val="col"/>
         <c:grouping val="clustered"/>
         <c:varyColors val="0"/>
         <c:ser>
@@ -183,7 +183,7 @@
               <c:strCache>
                 <c:ptCount val="1"/>
                 <c:pt idx="0">
-                  <c:v>Citas en Google AI Overviews</c:v>
+                  <c:v>Pauta (Google + Meta)</c:v>
                 </c:pt>
               </c:strCache>
             </c:strRef>
@@ -219,81 +219,20 @@
             <c:showBubbleSize val="0"/>
             <c:showLeaderLines val="0"/>
           </c:dLbls>
-          <c:dPt>
-            <c:idx val="0"/>
-            <c:invertIfNegative val="0"/>
-            <c:bubble3D val="0"/>
-            <c:spPr>
-              <a:solidFill>
-                <a:srgbClr val="D9701A"/>
-              </a:solidFill>
-              <a:effectLst/>
-            </c:spPr>
-          </c:dPt>
-          <c:dPt>
-            <c:idx val="1"/>
-            <c:invertIfNegative val="0"/>
-            <c:bubble3D val="0"/>
-            <c:spPr>
-              <a:solidFill>
-                <a:srgbClr val="9FB3C4"/>
-              </a:solidFill>
-              <a:effectLst/>
-            </c:spPr>
-          </c:dPt>
-          <c:dPt>
-            <c:idx val="2"/>
-            <c:invertIfNegative val="0"/>
-            <c:bubble3D val="0"/>
-            <c:spPr>
-              <a:solidFill>
-                <a:srgbClr val="9FB3C4"/>
-              </a:solidFill>
-              <a:effectLst/>
-            </c:spPr>
-          </c:dPt>
-          <c:dPt>
-            <c:idx val="3"/>
-            <c:invertIfNegative val="0"/>
-            <c:bubble3D val="0"/>
-            <c:spPr>
-              <a:solidFill>
-                <a:srgbClr val="1B3A52"/>
-              </a:solidFill>
-              <a:effectLst/>
-            </c:spPr>
-          </c:dPt>
-          <c:dPt>
-            <c:idx val="4"/>
-            <c:invertIfNegative val="0"/>
-            <c:bubble3D val="0"/>
-            <c:spPr>
-              <a:solidFill>
-                <a:srgbClr val="1B3A52"/>
-              </a:solidFill>
-              <a:effectLst/>
-            </c:spPr>
-          </c:dPt>
           <c:cat>
             <c:multiLvlStrRef>
-              <c:f>Sheet1!$A$2:$A$6</c:f>
+              <c:f>Sheet1!$A$2:$A$4</c:f>
               <c:multiLvlStrCache>
-                <c:ptCount val="5"/>
+                <c:ptCount val="3"/>
                 <c:lvl>
                   <c:pt idx="0">
-                    <c:v>GLT</c:v>
+                    <c:v>Leads</c:v>
                   </c:pt>
                   <c:pt idx="1">
-                    <c:v>BringGo</c:v>
+                    <c:v>Calificados</c:v>
                   </c:pt>
                   <c:pt idx="2">
-                    <c:v>Go Freight AI</c:v>
-                  </c:pt>
-                  <c:pt idx="3">
-                    <c:v>ExFreight</c:v>
-                  </c:pt>
-                  <c:pt idx="4">
-                    <c:v>Warp</c:v>
+                    <c:v>Clientes</c:v>
                   </c:pt>
                 </c:lvl>
               </c:multiLvlStrCache>
@@ -301,24 +240,101 @@
           </c:cat>
           <c:val>
             <c:numRef>
-              <c:f>Sheet1!$B$2:$B$6</c:f>
+              <c:f>Sheet1!$B$2:$B$4</c:f>
               <c:numCache>
                 <c:formatCode>General</c:formatCode>
-                <c:ptCount val="5"/>
+                <c:ptCount val="3"/>
                 <c:pt idx="0">
-                  <c:v>7</c:v>
+                  <c:v>70</c:v>
                 </c:pt>
                 <c:pt idx="1">
-                  <c:v>26</c:v>
+                  <c:v>18</c:v>
                 </c:pt>
                 <c:pt idx="2">
-                  <c:v>29</c:v>
+                  <c:v>1</c:v>
                 </c:pt>
-                <c:pt idx="3">
-                  <c:v>957</c:v>
+              </c:numCache>
+            </c:numRef>
+          </c:val>
+        </c:ser>
+        <c:ser>
+          <c:idx val="1"/>
+          <c:order val="1"/>
+          <c:tx>
+            <c:strRef>
+              <c:f>Sheet1!$C$1</c:f>
+              <c:strCache>
+                <c:ptCount val="1"/>
+                <c:pt idx="0">
+                  <c:v>Orgánico + directo</c:v>
                 </c:pt>
-                <c:pt idx="4">
-                  <c:v>1138</c:v>
+              </c:strCache>
+            </c:strRef>
+          </c:tx>
+          <c:spPr>
+            <a:solidFill>
+              <a:srgbClr val="1B3A52"/>
+            </a:solidFill>
+            <a:effectLst/>
+          </c:spPr>
+          <c:invertIfNegative val="0"/>
+          <c:dLbls>
+            <c:numFmt formatCode="#,##0" sourceLinked="0"/>
+            <c:txPr>
+              <a:bodyPr/>
+              <a:lstStyle/>
+              <a:p>
+                <a:pPr>
+                  <a:defRPr b="0" i="0" strike="noStrike" sz="1100" u="none">
+                    <a:solidFill>
+                      <a:srgbClr val="13202A"/>
+                    </a:solidFill>
+                    <a:latin typeface="+mn-lt"/>
+                  </a:defRPr>
+                </a:pPr>
+              </a:p>
+            </c:txPr>
+            <c:showLegendKey val="0"/>
+            <c:showVal val="1"/>
+            <c:showCatName val="0"/>
+            <c:showSerName val="0"/>
+            <c:showPercent val="0"/>
+            <c:showBubbleSize val="0"/>
+            <c:showLeaderLines val="0"/>
+          </c:dLbls>
+          <c:cat>
+            <c:multiLvlStrRef>
+              <c:f>Sheet1!$A$2:$A$4</c:f>
+              <c:multiLvlStrCache>
+                <c:ptCount val="3"/>
+                <c:lvl>
+                  <c:pt idx="0">
+                    <c:v>Leads</c:v>
+                  </c:pt>
+                  <c:pt idx="1">
+                    <c:v>Calificados</c:v>
+                  </c:pt>
+                  <c:pt idx="2">
+                    <c:v>Clientes</c:v>
+                  </c:pt>
+                </c:lvl>
+              </c:multiLvlStrCache>
+            </c:multiLvlStrRef>
+          </c:cat>
+          <c:val>
+            <c:numRef>
+              <c:f>Sheet1!$C$2:$C$4</c:f>
+              <c:numCache>
+                <c:formatCode>General</c:formatCode>
+                <c:ptCount val="3"/>
+                <c:pt idx="0">
+                  <c:v>186</c:v>
+                </c:pt>
+                <c:pt idx="1">
+                  <c:v>90</c:v>
+                </c:pt>
+                <c:pt idx="2">
+                  <c:v>18</c:v>
                 </c:pt>
               </c:numCache>
             </c:numRef>
@@ -348,7 +364,7 @@
           <c:showBubbleSize val="0"/>
           <c:showLeaderLines val="0"/>
         </c:dLbls>
-        <c:gapWidth val="45"/>
+        <c:gapWidth val="60"/>
         <c:overlap val="0"/>
         <c:axId val="2094734554"/>
         <c:axId val="2094734552"/>
@@ -360,8 +376,49 @@
           <c:orientation val="minMax"/>
         </c:scaling>
         <c:delete val="0"/>
+        <c:axPos val="b"/>
+        <c:numFmt formatCode="General" sourceLinked="1"/>
+        <c:majorTickMark val="out"/>
+        <c:minorTickMark val="none"/>
+        <c:tickLblPos val="low"/>
+        <c:spPr>
+          <a:ln w="12700" cap="flat">
+            <a:solidFill>
+              <a:srgbClr val="888888"/>
+            </a:solidFill>
+            <a:prstDash val="solid"/>
+            <a:round/>
+          </a:ln>
+        </c:spPr>
+        <c:txPr>
+          <a:bodyPr/>
+          <a:lstStyle/>
+          <a:p>
+            <a:pPr>
+              <a:defRPr sz="1100" b="0" i="0" u="none" strike="noStrike">
+                <a:solidFill>
+                  <a:srgbClr val="5A6873"/>
+                </a:solidFill>
+                <a:latin typeface="+mn-lt"/>
+              </a:defRPr>
+            </a:pPr>
+            <a:endParaRPr lang="en-US"/>
+          </a:p>
+        </c:txPr>
+        <c:crossAx val="2094734552"/>
+        <c:crosses val="autoZero"/>
+        <c:auto val="1"/>
+        <c:lblAlgn val="ctr"/>
+        <c:noMultiLvlLbl val="1"/>
+      </c:catAx>
+      <c:valAx>
+        <c:axId val="2094734552"/>
+        <c:scaling>
+          <c:orientation val="minMax"/>
+        </c:scaling>
+        <c:delete val="1"/>
         <c:axPos val="l"/>
-        <c:numFmt formatCode="General" sourceLinked="1"/>
+        <c:numFmt formatCode="General" sourceLinked="0"/>
         <c:majorTickMark val="out"/>
         <c:minorTickMark val="none"/>
         <c:tickLblPos val="nextTo"/>
@@ -379,47 +436,6 @@
           <a:lstStyle/>
           <a:p>
             <a:pPr>
-              <a:defRPr sz="1100" b="0" i="0" u="none" strike="noStrike">
-                <a:solidFill>
-                  <a:srgbClr val="5A6873"/>
-                </a:solidFill>
-                <a:latin typeface="+mn-lt"/>
-              </a:defRPr>
-            </a:pPr>
-            <a:endParaRPr lang="en-US"/>
-          </a:p>
-        </c:txPr>
-        <c:crossAx val="2094734552"/>
-        <c:crosses val="autoZero"/>
-        <c:auto val="1"/>
-        <c:lblAlgn val="ctr"/>
-        <c:noMultiLvlLbl val="1"/>
-      </c:catAx>
-      <c:valAx>
-        <c:axId val="2094734552"/>
-        <c:scaling>
-          <c:orientation val="minMax"/>
-        </c:scaling>
-        <c:delete val="1"/>
-        <c:axPos val="b"/>
-        <c:numFmt formatCode="General" sourceLinked="0"/>
-        <c:majorTickMark val="out"/>
-        <c:minorTickMark val="none"/>
-        <c:tickLblPos val="low"/>
-        <c:spPr>
-          <a:ln w="12700" cap="flat">
-            <a:solidFill>
-              <a:srgbClr val="888888"/>
-            </a:solidFill>
-            <a:prstDash val="solid"/>
-            <a:round/>
-          </a:ln>
-        </c:spPr>
-        <c:txPr>
-          <a:bodyPr/>
-          <a:lstStyle/>
-          <a:p>
-            <a:pPr>
               <a:defRPr sz="1200" b="0" i="0" u="none" strike="noStrike">
                 <a:solidFill>
                   <a:srgbClr val="000000"/>
@@ -442,6 +458,26 @@
         <a:effectLst/>
       </c:spPr>
     </c:plotArea>
+    <c:legend>
+      <c:legendPos val="b"/>
+      <c:overlay val="0"/>
+      <c:txPr>
+        <a:bodyPr/>
+        <a:lstStyle/>
+        <a:p>
+          <a:pPr>
+            <a:defRPr sz="1000">
+              <a:solidFill>
+                <a:srgbClr val="13202A"/>
+              </a:solidFill>
+              <a:latin typeface="+mn-lt"/>
+              <a:cs typeface="+mn-lt"/>
+            </a:defRPr>
+          </a:pPr>
+          <a:endParaRPr lang="en-US"/>
+        </a:p>
+      </c:txPr>
+    </c:legend>
     <c:plotVisOnly val="1"/>
     <c:dispBlanksAs val="span"/>
   </c:chart>
@@ -477,7 +513,7 @@
               <c:strCache>
                 <c:ptCount val="1"/>
                 <c:pt idx="0">
-                  <c:v>Presupuesto base 2027</c:v>
+                  <c:v>Presupuesto 2027</c:v>
                 </c:pt>
               </c:strCache>
             </c:strRef>
@@ -500,7 +536,7 @@
             <c:bubble3D val="0"/>
             <c:spPr>
               <a:solidFill>
-                <a:srgbClr val="1B3A52"/>
+                <a:srgbClr val="D9701A"/>
               </a:solidFill>
               <a:effectLst/>
             </c:spPr>
@@ -510,7 +546,7 @@
             <c:bubble3D val="0"/>
             <c:spPr>
               <a:solidFill>
-                <a:srgbClr val="D9701A"/>
+                <a:srgbClr val="1B3A52"/>
               </a:solidFill>
               <a:effectLst/>
             </c:spPr>
@@ -630,10 +666,10 @@
               <c:strCache>
                 <c:ptCount val="3"/>
                 <c:pt idx="0">
-                  <c:v>Pauta digital</c:v>
+                  <c:v>Pauta digital (awareness + leads)</c:v>
                 </c:pt>
                 <c:pt idx="1">
-                  <c:v>SEO + GEO (contenido, /es/, herramientas, YouTube)</c:v>
+                  <c:v>SEO + GEO</c:v>
                 </c:pt>
                 <c:pt idx="2">
                   <c:v>Herramientas y medición</c:v>
@@ -647,13 +683,13 @@
               <c:numCache>
                 <c:ptCount val="3"/>
                 <c:pt idx="0">
-                  <c:v>96</c:v>
+                  <c:v>24</c:v>
                 </c:pt>
                 <c:pt idx="1">
-                  <c:v>60</c:v>
+                  <c:v>22</c:v>
                 </c:pt>
                 <c:pt idx="2">
-                  <c:v>10</c:v>
+                  <c:v>6</c:v>
                 </c:pt>
               </c:numCache>
             </c:numRef>
@@ -662,6 +698,436 @@
         <c:firstSliceAng val="0"/>
         <c:holeSize val="58"/>
       </c:doughnutChart>
+      <c:spPr>
+        <a:noFill/>
+        <a:ln>
+          <a:noFill/>
+        </a:ln>
+        <a:effectLst/>
+      </c:spPr>
+    </c:plotArea>
+    <c:legend>
+      <c:legendPos val="b"/>
+      <c:overlay val="0"/>
+      <c:txPr>
+        <a:bodyPr/>
+        <a:lstStyle/>
+        <a:p>
+          <a:pPr>
+            <a:defRPr sz="1000">
+              <a:solidFill>
+                <a:srgbClr val="13202A"/>
+              </a:solidFill>
+              <a:latin typeface="+mn-lt"/>
+              <a:cs typeface="+mn-lt"/>
+            </a:defRPr>
+          </a:pPr>
+          <a:endParaRPr lang="en-US"/>
+        </a:p>
+      </c:txPr>
+    </c:legend>
+    <c:plotVisOnly val="1"/>
+    <c:dispBlanksAs val="span"/>
+  </c:chart>
+  <c:spPr>
+    <a:noFill/>
+    <a:ln>
+      <a:noFill/>
+    </a:ln>
+    <a:effectLst/>
+  </c:spPr>
+  <c:externalData r:id="rId1">
+    <c:autoUpdate val="0"/>
+  </c:externalData>
+</c:chartSpace>
+</file>
+
+<file path=ppt/charts/chart3.xml><?xml version="1.0" encoding="utf-8"?>
+<c:chartSpace xmlns:c="http://schemas.openxmlformats.org/drawingml/2006/chart" xmlns:a="http://schemas.openxmlformats.org/drawingml/2006/main" xmlns:r="http://schemas.openxmlformats.org/officeDocument/2006/relationships">
+  <c:date1904 val="0"/>
+  <c:roundedCorners val="1"/>
+  <c:chart>
+    <c:title>
+      <c:tx>
+        <c:rich>
+          <a:bodyPr/>
+          <a:lstStyle/>
+          <a:p>
+            <a:pPr>
+              <a:defRPr sz="1200" b="0" i="0" u="none" strike="noStrike">
+                <a:solidFill>
+                  <a:srgbClr val="13202A"/>
+                </a:solidFill>
+                <a:latin typeface="+mn-lt"/>
+              </a:defRPr>
+            </a:pPr>
+            <a:r>
+              <a:rPr sz="1200" b="0" i="0" u="none" strike="noStrike">
+                <a:solidFill>
+                  <a:srgbClr val="13202A"/>
+                </a:solidFill>
+                <a:latin typeface="+mn-lt"/>
+              </a:rPr>
+              <a:t>Revenue de clientes nuevos (US$ miles)</a:t>
+            </a:r>
+          </a:p>
+        </c:rich>
+      </c:tx>
+      <c:layout/>
+      <c:overlay val="0"/>
+    </c:title>
+    <c:autoTitleDeleted val="0"/>
+    <c:plotArea>
+      <c:layout/>
+      <c:barChart>
+        <c:barDir val="col"/>
+        <c:grouping val="stacked"/>
+        <c:varyColors val="0"/>
+        <c:ser>
+          <c:idx val="0"/>
+          <c:order val="0"/>
+          <c:tx>
+            <c:strRef>
+              <c:f>Sheet1!$B$1</c:f>
+              <c:strCache>
+                <c:ptCount val="1"/>
+                <c:pt idx="0">
+                  <c:v>Pauta</c:v>
+                </c:pt>
+              </c:strCache>
+            </c:strRef>
+          </c:tx>
+          <c:spPr>
+            <a:solidFill>
+              <a:srgbClr val="D9701A"/>
+            </a:solidFill>
+            <a:effectLst/>
+          </c:spPr>
+          <c:invertIfNegative val="0"/>
+          <c:dLbls>
+            <c:numFmt formatCode="0;;;" sourceLinked="0"/>
+            <c:txPr>
+              <a:bodyPr/>
+              <a:lstStyle/>
+              <a:p>
+                <a:pPr>
+                  <a:defRPr b="0" i="0" strike="noStrike" sz="1100" u="none">
+                    <a:solidFill>
+                      <a:srgbClr val="FFFFFF"/>
+                    </a:solidFill>
+                    <a:latin typeface="+mn-lt"/>
+                  </a:defRPr>
+                </a:pPr>
+              </a:p>
+            </c:txPr>
+            <c:dLblPos val="ctr"/>
+            <c:showLegendKey val="0"/>
+            <c:showVal val="1"/>
+            <c:showCatName val="0"/>
+            <c:showSerName val="0"/>
+            <c:showPercent val="0"/>
+            <c:showBubbleSize val="0"/>
+            <c:showLeaderLines val="0"/>
+          </c:dLbls>
+          <c:cat>
+            <c:multiLvlStrRef>
+              <c:f>Sheet1!$A$2:$A$3</c:f>
+              <c:multiLvlStrCache>
+                <c:ptCount val="2"/>
+                <c:lvl>
+                  <c:pt idx="0">
+                    <c:v>2026 real</c:v>
+                  </c:pt>
+                  <c:pt idx="1">
+                    <c:v>2027 meta</c:v>
+                  </c:pt>
+                </c:lvl>
+              </c:multiLvlStrCache>
+            </c:multiLvlStrRef>
+          </c:cat>
+          <c:val>
+            <c:numRef>
+              <c:f>Sheet1!$B$2:$B$3</c:f>
+              <c:numCache>
+                <c:formatCode>General</c:formatCode>
+                <c:ptCount val="2"/>
+                <c:pt idx="0">
+                  <c:v>14.3</c:v>
+                </c:pt>
+                <c:pt idx="1">
+                  <c:v>25</c:v>
+                </c:pt>
+              </c:numCache>
+            </c:numRef>
+          </c:val>
+        </c:ser>
+        <c:ser>
+          <c:idx val="1"/>
+          <c:order val="1"/>
+          <c:tx>
+            <c:strRef>
+              <c:f>Sheet1!$C$1</c:f>
+              <c:strCache>
+                <c:ptCount val="1"/>
+                <c:pt idx="0">
+                  <c:v>Orgánico + directo (base)</c:v>
+                </c:pt>
+              </c:strCache>
+            </c:strRef>
+          </c:tx>
+          <c:spPr>
+            <a:solidFill>
+              <a:srgbClr val="1B3A52"/>
+            </a:solidFill>
+            <a:effectLst/>
+          </c:spPr>
+          <c:invertIfNegative val="0"/>
+          <c:dLbls>
+            <c:numFmt formatCode="0;;;" sourceLinked="0"/>
+            <c:txPr>
+              <a:bodyPr/>
+              <a:lstStyle/>
+              <a:p>
+                <a:pPr>
+                  <a:defRPr b="0" i="0" strike="noStrike" sz="1100" u="none">
+                    <a:solidFill>
+                      <a:srgbClr val="FFFFFF"/>
+                    </a:solidFill>
+                    <a:latin typeface="+mn-lt"/>
+                  </a:defRPr>
+                </a:pPr>
+              </a:p>
+            </c:txPr>
+            <c:dLblPos val="ctr"/>
+            <c:showLegendKey val="0"/>
+            <c:showVal val="1"/>
+            <c:showCatName val="0"/>
+            <c:showSerName val="0"/>
+            <c:showPercent val="0"/>
+            <c:showBubbleSize val="0"/>
+            <c:showLeaderLines val="0"/>
+          </c:dLbls>
+          <c:cat>
+            <c:multiLvlStrRef>
+              <c:f>Sheet1!$A$2:$A$3</c:f>
+              <c:multiLvlStrCache>
+                <c:ptCount val="2"/>
+                <c:lvl>
+                  <c:pt idx="0">
+                    <c:v>2026 real</c:v>
+                  </c:pt>
+                  <c:pt idx="1">
+                    <c:v>2027 meta</c:v>
+                  </c:pt>
+                </c:lvl>
+              </c:multiLvlStrCache>
+            </c:multiLvlStrRef>
+          </c:cat>
+          <c:val>
+            <c:numRef>
+              <c:f>Sheet1!$C$2:$C$3</c:f>
+              <c:numCache>
+                <c:formatCode>General</c:formatCode>
+                <c:ptCount val="2"/>
+                <c:pt idx="0">
+                  <c:v>83</c:v>
+                </c:pt>
+                <c:pt idx="1">
+                  <c:v>83</c:v>
+                </c:pt>
+              </c:numCache>
+            </c:numRef>
+          </c:val>
+        </c:ser>
+        <c:ser>
+          <c:idx val="2"/>
+          <c:order val="2"/>
+          <c:tx>
+            <c:strRef>
+              <c:f>Sheet1!$D$1</c:f>
+              <c:strCache>
+                <c:ptCount val="1"/>
+                <c:pt idx="0">
+                  <c:v>SEO + GEO (nuevo)</c:v>
+                </c:pt>
+              </c:strCache>
+            </c:strRef>
+          </c:tx>
+          <c:spPr>
+            <a:solidFill>
+              <a:srgbClr val="1F7A4D"/>
+            </a:solidFill>
+            <a:effectLst/>
+          </c:spPr>
+          <c:invertIfNegative val="0"/>
+          <c:dLbls>
+            <c:numFmt formatCode="0;;;" sourceLinked="0"/>
+            <c:txPr>
+              <a:bodyPr/>
+              <a:lstStyle/>
+              <a:p>
+                <a:pPr>
+                  <a:defRPr b="0" i="0" strike="noStrike" sz="1100" u="none">
+                    <a:solidFill>
+                      <a:srgbClr val="FFFFFF"/>
+                    </a:solidFill>
+                    <a:latin typeface="+mn-lt"/>
+                  </a:defRPr>
+                </a:pPr>
+              </a:p>
+            </c:txPr>
+            <c:dLblPos val="ctr"/>
+            <c:showLegendKey val="0"/>
+            <c:showVal val="1"/>
+            <c:showCatName val="0"/>
+            <c:showSerName val="0"/>
+            <c:showPercent val="0"/>
+            <c:showBubbleSize val="0"/>
+            <c:showLeaderLines val="0"/>
+          </c:dLbls>
+          <c:cat>
+            <c:multiLvlStrRef>
+              <c:f>Sheet1!$A$2:$A$3</c:f>
+              <c:multiLvlStrCache>
+                <c:ptCount val="2"/>
+                <c:lvl>
+                  <c:pt idx="0">
+                    <c:v>2026 real</c:v>
+                  </c:pt>
+                  <c:pt idx="1">
+                    <c:v>2027 meta</c:v>
+                  </c:pt>
+                </c:lvl>
+              </c:multiLvlStrCache>
+            </c:multiLvlStrRef>
+          </c:cat>
+          <c:val>
+            <c:numRef>
+              <c:f>Sheet1!$D$2:$D$3</c:f>
+              <c:numCache>
+                <c:formatCode>General</c:formatCode>
+                <c:ptCount val="2"/>
+                <c:pt idx="0">
+                  <c:v>0</c:v>
+                </c:pt>
+                <c:pt idx="1">
+                  <c:v>28</c:v>
+                </c:pt>
+              </c:numCache>
+            </c:numRef>
+          </c:val>
+        </c:ser>
+        <c:dLbls>
+          <c:numFmt formatCode="0;;;" sourceLinked="0"/>
+          <c:txPr>
+            <a:bodyPr/>
+            <a:lstStyle/>
+            <a:p>
+              <a:pPr>
+                <a:defRPr b="0" i="0" strike="noStrike" sz="1100" u="none">
+                  <a:solidFill>
+                    <a:srgbClr val="FFFFFF"/>
+                  </a:solidFill>
+                  <a:latin typeface="+mn-lt"/>
+                </a:defRPr>
+              </a:pPr>
+            </a:p>
+          </c:txPr>
+          <c:dLblPos val="ctr"/>
+          <c:showLegendKey val="0"/>
+          <c:showVal val="1"/>
+          <c:showCatName val="0"/>
+          <c:showSerName val="0"/>
+          <c:showPercent val="0"/>
+          <c:showBubbleSize val="0"/>
+          <c:showLeaderLines val="0"/>
+        </c:dLbls>
+        <c:gapWidth val="55"/>
+        <c:overlap val="100"/>
+        <c:axId val="2094734554"/>
+        <c:axId val="2094734552"/>
+        <c:axId val="2094734556"/>
+      </c:barChart>
+      <c:catAx>
+        <c:axId val="2094734554"/>
+        <c:scaling>
+          <c:orientation val="minMax"/>
+        </c:scaling>
+        <c:delete val="0"/>
+        <c:axPos val="b"/>
+        <c:numFmt formatCode="General" sourceLinked="1"/>
+        <c:majorTickMark val="out"/>
+        <c:minorTickMark val="none"/>
+        <c:tickLblPos val="low"/>
+        <c:spPr>
+          <a:ln w="12700" cap="flat">
+            <a:solidFill>
+              <a:srgbClr val="888888"/>
+            </a:solidFill>
+            <a:prstDash val="solid"/>
+            <a:round/>
+          </a:ln>
+        </c:spPr>
+        <c:txPr>
+          <a:bodyPr/>
+          <a:lstStyle/>
+          <a:p>
+            <a:pPr>
+              <a:defRPr sz="1100" b="0" i="0" u="none" strike="noStrike">
+                <a:solidFill>
+                  <a:srgbClr val="5A6873"/>
+                </a:solidFill>
+                <a:latin typeface="+mn-lt"/>
+              </a:defRPr>
+            </a:pPr>
+            <a:endParaRPr lang="en-US"/>
+          </a:p>
+        </c:txPr>
+        <c:crossAx val="2094734552"/>
+        <c:crosses val="autoZero"/>
+        <c:auto val="1"/>
+        <c:lblAlgn val="ctr"/>
+        <c:noMultiLvlLbl val="1"/>
+      </c:catAx>
+      <c:valAx>
+        <c:axId val="2094734552"/>
+        <c:scaling>
+          <c:orientation val="minMax"/>
+        </c:scaling>
+        <c:delete val="1"/>
+        <c:axPos val="l"/>
+        <c:numFmt formatCode="General" sourceLinked="0"/>
+        <c:majorTickMark val="out"/>
+        <c:minorTickMark val="none"/>
+        <c:tickLblPos val="nextTo"/>
+        <c:spPr>
+          <a:ln w="12700" cap="flat">
+            <a:solidFill>
+              <a:srgbClr val="888888"/>
+            </a:solidFill>
+            <a:prstDash val="solid"/>
+            <a:round/>
+          </a:ln>
+        </c:spPr>
+        <c:txPr>
+          <a:bodyPr/>
+          <a:lstStyle/>
+          <a:p>
+            <a:pPr>
+              <a:defRPr sz="1200" b="0" i="0" u="none" strike="noStrike">
+                <a:solidFill>
+                  <a:srgbClr val="000000"/>
+                </a:solidFill>
+                <a:latin typeface="Arial"/>
+              </a:defRPr>
+            </a:pPr>
+            <a:endParaRPr lang="en-US"/>
+          </a:p>
+        </c:txPr>
+        <c:crossAx val="2094734554"/>
+        <c:crosses val="autoZero"/>
+        <c:crossBetween val="between"/>
+      </c:valAx>
       <c:spPr>
         <a:noFill/>
         <a:ln>
@@ -1101,7 +1567,7 @@
           <a:p>
             <a:r>
               <a:rPr lang="en-US" dirty="0"/>
-              <a:t>Mensaje: tenemos los mejores activos del nicho (integración nativa con Magaya, LTL de marca blanca para brokers, México, equipos bilingües), pero Google y la IA no nos ven. Unas 8 de cada 10 visitas orgánicas (~1.550 de ~1.859 al mes) llegan buscando "GLT" por nombre; en búsquedas de categoría no aparecemos. La IA de Google cita a Warp 1.138 veces y a nosotros 7. Además, cuando se le pregunta a la IA por un programa LTL de marca blanca para brokers, responde que no encuentra ninguno: es exactamente lo que vendemos. Fuente: OpenRush, 28 oct 2026 (estimaciones del proveedor).</a:t>
+              <a:t>Mensaje: en 2026 invertimos US$15.000 en pauta (Google Search y Meta): 70 leads, 18 calificados, 1 venta de US$14.330. CPL US$214, costo por lead calificado US$833, CAC US$15.000, ROAS 0,96x sobre revenue (no sobre margen). Orgánico + directo trajo 186 leads, 90 calificados y 18 clientes por US$83.000: 95% de los clientes y 85% del revenue. Calidad: 48% de los leads orgánicos califican (pauta 26%) y 20% de los calificados cierran (pauta 5,6%). Matiz importante: 'orgánico + directo' incluye a quien ya nos conoce (marca, referidos); 8 de cada 10 visitas orgánicas buscan 'GLT' por nombre. El motor funciona, pero solo con demanda que ya existe. Con 1 sola venta por pauta, la muestra es pequeña; no concluimos que la pauta no sirve, sino que como la hicimos no se paga.</a:t>
             </a:r>
             <a:endParaRPr lang="en-US" dirty="0"/>
           </a:p>
@@ -1189,7 +1655,7 @@
           <a:p>
             <a:r>
               <a:rPr lang="en-US" dirty="0"/>
-              <a:t>Mensaje: no pedimos un cheque en blanco. US$166K base: US$96K de pauta (US$8K/mes), US$60K de SEO y GEO (contenido, landings, sitio en español, herramientas gratuitas, YouTube) y US$10K de herramientas y medición. Una reserva de US$24K solo se libera si el piloto funciona. Escenario de equilibrio (no pronóstico): con ~20–45 leads al mes y 10% de activación, son 24–54 cuentas nuevas al año; la pauta se paga si cada cuenta deja entre US$1,8K y US$4K de margen en sus primeros 6 meses. Finanzas debe validar ese margen. CPC: OpenRush; benchmarks: WordStream 2026, Metadata (LinkedIn).</a:t>
+              <a:t>Mensaje: el presupuesto crece de forma proporcional a la evidencia. Pauta: US$24K (60% más que 2026) pero rediseñada. Salimos de Meta como canal de captación en frío (queda solo para remarketing, agentes y carriers), concentramos Google en búsquedas de nicho y en español en México (clic de ~US$3 frente a US$16–30 en EE. UU.), y probamos LinkedIn a cuentas objetivo con US$4,8K. SEO + GEO: US$22K para que el canal que ya trae el 95% de los clientes encuentre demanda nueva, no solo la de quien ya nos conoce. Herramientas: US$6K. Reglas: liberación trimestral, meta de costo por cliente ≤US$5K, y si al cierre del Q2 supera US$8K, el saldo se mueve a SEO + GEO. Pendiente con Finanzas: margen bruto y retención por cliente para calcular el valor de vida.</a:t>
             </a:r>
             <a:endParaRPr lang="en-US" dirty="0"/>
           </a:p>
@@ -1277,7 +1743,7 @@
           <a:p>
             <a:r>
               <a:rPr lang="en-US" dirty="0"/>
-              <a:t>Mensaje: la ventana es concreta. Warp domina el LTL doméstico pero su propio sitio dice que no cruza la frontera ni atiende en español. La MVE es obligatoria desde el 1 de octubre de 2026 y el corredor crece (+29,8% en camión, BTS ago 2026). Metas 2027: tráfico sin marca por encima del 40% del orgánico, citas en la IA de Google de 7 a 70 o más, aparecer en 5 de 8 preguntas de compradores a los 90 días. Son metas de seguimiento, no promesas: nadie puede garantizar posiciones ni que una IA recomiende a una empresa.</a:t>
+              <a:t>Mensaje: con US$52K buscamos pasar de US$97K a US$130–150K de revenue de clientes nuevos traídos por marketing, y de 19 a ~30 clientes. Supuestos (escenario, no pronóstico): pauta con CPL ~US$200, 35% de leads calificados y 12% de cierre = ~5 clientes y ~US$25K; orgánico + directo se mantiene en US$83K; SEO + GEO suma ~75 leads nuevos sin marca, ~6 clientes y ~US$23–37K, asumiendo que convierten la mitad de bien que los leads de marca. El retorno del primer año sobre el incremento de inversión es cercano a 1x; el caso se completa con la recompra de los clientes (valor de vida), que Finanzas debe confirmar. Si al cierre del Q2 la pauta no cumple, movemos el saldo al motor orgánico.</a:t>
             </a:r>
             <a:endParaRPr lang="en-US" dirty="0"/>
           </a:p>
@@ -1879,22 +2345,38 @@
                 <a:ea typeface="Cambria" pitchFamily="34" charset="-122"/>
                 <a:cs typeface="Cambria" pitchFamily="34" charset="-120"/>
               </a:rPr>
-              <a:t>Hoy solo nos encuentra quien ya nos conoce</a:t>
+              <a:t>2026: el orgánico trajo 95% de los clientes</a:t>
             </a:r>
             <a:endParaRPr lang="en-US" sz="2600" dirty="0"/>
           </a:p>
         </p:txBody>
       </p:sp>
-      <p:sp>
-        <p:nvSpPr>
-          <p:cNvPr id="3" name="stat-card-1"/>
+      <p:graphicFrame>
+        <p:nvGraphicFramePr>
+          <p:cNvPr id="3" name="chart-funnel-2026" descr=""/>
+          <p:cNvGraphicFramePr/>
+          <p:nvPr/>
+        </p:nvGraphicFramePr>
+        <p:xfrm>
+          <a:off x="365760" y="1005840"/>
+          <a:ext cx="4572000" cy="2743200"/>
+        </p:xfrm>
+        <a:graphic xmlns:a="http://schemas.openxmlformats.org/drawingml/2006/main">
+          <a:graphicData uri="http://schemas.openxmlformats.org/drawingml/2006/chart">
+            <c:chart xmlns:c="http://schemas.openxmlformats.org/drawingml/2006/chart" r:id="rId1"/>
+          </a:graphicData>
+        </a:graphic>
+      </p:graphicFrame>
+      <p:sp>
+        <p:nvSpPr>
+          <p:cNvPr id="4" name="card-brand-note"/>
           <p:cNvSpPr/>
           <p:nvPr/>
         </p:nvSpPr>
         <p:spPr>
           <a:xfrm>
-            <a:off x="457200" y="1097280"/>
-            <a:ext cx="3291840" cy="1051560"/>
+            <a:off x="457200" y="3840480"/>
+            <a:ext cx="4389120" cy="822960"/>
           </a:xfrm>
           <a:prstGeom prst="rect">
             <a:avLst/>
@@ -1912,14 +2394,14 @@
       </p:sp>
       <p:sp>
         <p:nvSpPr>
-          <p:cNvPr id="4" name="stat-num-1"/>
+          <p:cNvPr id="5" name="text-brand-note"/>
           <p:cNvSpPr txBox="1"/>
           <p:nvPr/>
         </p:nvSpPr>
         <p:spPr>
           <a:xfrm>
-            <a:off x="640080" y="1188720"/>
-            <a:ext cx="2926080" cy="502920"/>
+            <a:off x="594360" y="3886200"/>
+            <a:ext cx="4160520" cy="731520"/>
           </a:xfrm>
           <a:prstGeom prst="rect">
             <a:avLst/>
@@ -1935,41 +2417,13 @@
               <a:buNone/>
             </a:pPr>
             <a:r>
-              <a:rPr lang="en-US" sz="3000" b="1" dirty="0">
+              <a:rPr lang="en-US" sz="1200" b="1" dirty="0">
                 <a:solidFill>
-                  <a:schemeClr val="accent1"/>
+                  <a:schemeClr val="tx2"/>
                 </a:solidFill>
-                <a:latin typeface="Cambria" pitchFamily="34" charset="0"/>
-                <a:ea typeface="Cambria" pitchFamily="34" charset="-122"/>
-                <a:cs typeface="Cambria" pitchFamily="34" charset="-120"/>
               </a:rPr>
-              <a:t>8 de 10</a:t>
+              <a:t>Pero el motor depende de la marca: </a:t>
             </a:r>
-            <a:endParaRPr lang="en-US" sz="3000" dirty="0"/>
-          </a:p>
-        </p:txBody>
-      </p:sp>
-      <p:sp>
-        <p:nvSpPr>
-          <p:cNvPr id="5" name="stat-label-1"/>
-          <p:cNvSpPr txBox="1"/>
-          <p:nvPr/>
-        </p:nvSpPr>
-        <p:spPr>
-          <a:xfrm>
-            <a:off x="640080" y="1664208"/>
-            <a:ext cx="2971800" cy="438912"/>
-          </a:xfrm>
-          <a:prstGeom prst="rect">
-            <a:avLst/>
-          </a:prstGeom>
-          <a:noFill/>
-          <a:ln/>
-        </p:spPr>
-        <p:txBody>
-          <a:bodyPr wrap="square" lIns="0" tIns="0" rIns="0" bIns="0" rtlCol="0" anchor="t"/>
-          <a:lstStyle/>
-          <a:p>
             <a:pPr indent="0" marL="0">
               <a:buNone/>
             </a:pPr>
@@ -1979,7 +2433,7 @@
                   <a:schemeClr val="tx1"/>
                 </a:solidFill>
               </a:rPr>
-              <a:t>visitas orgánicas vienen de gente que ya busca "GLT" por nombre</a:t>
+              <a:t>8 de cada 10 visitas orgánicas buscan "GLT" por nombre, y la IA de Google nos cita 7 veces frente a 1.138 de Warp.</a:t>
             </a:r>
             <a:endParaRPr lang="en-US" sz="1200" dirty="0"/>
           </a:p>
@@ -1987,14 +2441,14 @@
       </p:sp>
       <p:sp>
         <p:nvSpPr>
-          <p:cNvPr id="6" name="stat-card-2"/>
+          <p:cNvPr id="6" name="stat-card-1"/>
           <p:cNvSpPr/>
           <p:nvPr/>
         </p:nvSpPr>
         <p:spPr>
           <a:xfrm>
-            <a:off x="457200" y="2286000"/>
-            <a:ext cx="3291840" cy="1051560"/>
+            <a:off x="5212080" y="1005840"/>
+            <a:ext cx="3474720" cy="1097280"/>
           </a:xfrm>
           <a:prstGeom prst="rect">
             <a:avLst/>
@@ -2012,14 +2466,14 @@
       </p:sp>
       <p:sp>
         <p:nvSpPr>
-          <p:cNvPr id="7" name="stat-num-2"/>
+          <p:cNvPr id="7" name="stat-num-1"/>
           <p:cNvSpPr txBox="1"/>
           <p:nvPr/>
         </p:nvSpPr>
         <p:spPr>
           <a:xfrm>
-            <a:off x="640080" y="2377440"/>
-            <a:ext cx="2926080" cy="502920"/>
+            <a:off x="5394960" y="1097280"/>
+            <a:ext cx="3108960" cy="457200"/>
           </a:xfrm>
           <a:prstGeom prst="rect">
             <a:avLst/>
@@ -2035,7 +2489,7 @@
               <a:buNone/>
             </a:pPr>
             <a:r>
-              <a:rPr lang="en-US" sz="3000" b="1" dirty="0">
+              <a:rPr lang="en-US" sz="2600" b="1" dirty="0">
                 <a:solidFill>
                   <a:schemeClr val="accent1"/>
                 </a:solidFill>
@@ -2043,22 +2497,22 @@
                 <a:ea typeface="Cambria" pitchFamily="34" charset="-122"/>
                 <a:cs typeface="Cambria" pitchFamily="34" charset="-120"/>
               </a:rPr>
-              <a:t>0 de 10</a:t>
+              <a:t>95%</a:t>
             </a:r>
-            <a:endParaRPr lang="en-US" sz="3000" dirty="0"/>
+            <a:endParaRPr lang="en-US" sz="2600" dirty="0"/>
           </a:p>
         </p:txBody>
       </p:sp>
       <p:sp>
         <p:nvSpPr>
-          <p:cNvPr id="8" name="stat-label-2"/>
+          <p:cNvPr id="8" name="stat-label-1"/>
           <p:cNvSpPr txBox="1"/>
           <p:nvPr/>
         </p:nvSpPr>
         <p:spPr>
           <a:xfrm>
-            <a:off x="640080" y="2852928"/>
-            <a:ext cx="2971800" cy="438912"/>
+            <a:off x="5394960" y="1554480"/>
+            <a:ext cx="3154680" cy="502920"/>
           </a:xfrm>
           <a:prstGeom prst="rect">
             <a:avLst/>
@@ -2079,7 +2533,7 @@
                   <a:schemeClr val="tx1"/>
                 </a:solidFill>
               </a:rPr>
-              <a:t>búsquedas clave de nuestra categoría donde aparecemos en el top 30</a:t>
+              <a:t>de los clientes nuevos (18 de 19) y 85% del revenue vinieron de orgánico + directo</a:t>
             </a:r>
             <a:endParaRPr lang="en-US" sz="1200" dirty="0"/>
           </a:p>
@@ -2087,14 +2541,14 @@
       </p:sp>
       <p:sp>
         <p:nvSpPr>
-          <p:cNvPr id="9" name="stat-card-3"/>
+          <p:cNvPr id="9" name="stat-card-2"/>
           <p:cNvSpPr/>
           <p:nvPr/>
         </p:nvSpPr>
         <p:spPr>
           <a:xfrm>
-            <a:off x="457200" y="3474720"/>
-            <a:ext cx="3291840" cy="1051560"/>
+            <a:off x="5212080" y="2240280"/>
+            <a:ext cx="3474720" cy="1097280"/>
           </a:xfrm>
           <a:prstGeom prst="rect">
             <a:avLst/>
@@ -2112,14 +2566,14 @@
       </p:sp>
       <p:sp>
         <p:nvSpPr>
-          <p:cNvPr id="10" name="stat-num-3"/>
+          <p:cNvPr id="10" name="stat-num-2"/>
           <p:cNvSpPr txBox="1"/>
           <p:nvPr/>
         </p:nvSpPr>
         <p:spPr>
           <a:xfrm>
-            <a:off x="640080" y="3566160"/>
-            <a:ext cx="2926080" cy="502920"/>
+            <a:off x="5394960" y="2331720"/>
+            <a:ext cx="3108960" cy="457200"/>
           </a:xfrm>
           <a:prstGeom prst="rect">
             <a:avLst/>
@@ -2135,7 +2589,7 @@
               <a:buNone/>
             </a:pPr>
             <a:r>
-              <a:rPr lang="en-US" sz="3000" b="1" dirty="0">
+              <a:rPr lang="en-US" sz="2600" b="1" dirty="0">
                 <a:solidFill>
                   <a:schemeClr val="accent1"/>
                 </a:solidFill>
@@ -2143,22 +2597,22 @@
                 <a:ea typeface="Cambria" pitchFamily="34" charset="-122"/>
                 <a:cs typeface="Cambria" pitchFamily="34" charset="-120"/>
               </a:rPr>
-              <a:t>7 vs. 1.138</a:t>
+              <a:t>US$15K</a:t>
             </a:r>
-            <a:endParaRPr lang="en-US" sz="3000" dirty="0"/>
+            <a:endParaRPr lang="en-US" sz="2600" dirty="0"/>
           </a:p>
         </p:txBody>
       </p:sp>
       <p:sp>
         <p:nvSpPr>
-          <p:cNvPr id="11" name="stat-label-3"/>
+          <p:cNvPr id="11" name="stat-label-2"/>
           <p:cNvSpPr txBox="1"/>
           <p:nvPr/>
         </p:nvSpPr>
         <p:spPr>
           <a:xfrm>
-            <a:off x="640080" y="4041648"/>
-            <a:ext cx="2971800" cy="438912"/>
+            <a:off x="5394960" y="2788920"/>
+            <a:ext cx="3154680" cy="502920"/>
           </a:xfrm>
           <a:prstGeom prst="rect">
             <a:avLst/>
@@ -2179,38 +2633,22 @@
                   <a:schemeClr val="tx1"/>
                 </a:solidFill>
               </a:rPr>
-              <a:t>veces que la IA de Google nos cita como fuente, frente a Warp</a:t>
+              <a:t>costó cada cliente por pauta en 2026 (1 venta; ROAS 0,96x en revenue)</a:t>
             </a:r>
             <a:endParaRPr lang="en-US" sz="1200" dirty="0"/>
           </a:p>
         </p:txBody>
       </p:sp>
-      <p:graphicFrame>
-        <p:nvGraphicFramePr>
-          <p:cNvPr id="12" name="chart-ai-citations" descr=""/>
-          <p:cNvGraphicFramePr/>
-          <p:nvPr/>
-        </p:nvGraphicFramePr>
-        <p:xfrm>
-          <a:off x="4023360" y="1051560"/>
-          <a:ext cx="4663440" cy="2606040"/>
-        </p:xfrm>
-        <a:graphic xmlns:a="http://schemas.openxmlformats.org/drawingml/2006/main">
-          <a:graphicData uri="http://schemas.openxmlformats.org/drawingml/2006/chart">
-            <c:chart xmlns:c="http://schemas.openxmlformats.org/drawingml/2006/chart" r:id="rId1"/>
-          </a:graphicData>
-        </a:graphic>
-      </p:graphicFrame>
-      <p:sp>
-        <p:nvSpPr>
-          <p:cNvPr id="13" name="callout-traffic-value"/>
+      <p:sp>
+        <p:nvSpPr>
+          <p:cNvPr id="12" name="stat-card-3"/>
           <p:cNvSpPr/>
           <p:nvPr/>
         </p:nvSpPr>
         <p:spPr>
           <a:xfrm>
-            <a:off x="4023360" y="3794760"/>
-            <a:ext cx="4663440" cy="868680"/>
+            <a:off x="5212080" y="3474720"/>
+            <a:ext cx="3474720" cy="1097280"/>
           </a:xfrm>
           <a:prstGeom prst="rect">
             <a:avLst/>
@@ -2228,14 +2666,14 @@
       </p:sp>
       <p:sp>
         <p:nvSpPr>
-          <p:cNvPr id="14" name="callout-traffic-text"/>
+          <p:cNvPr id="13" name="stat-num-3"/>
           <p:cNvSpPr txBox="1"/>
           <p:nvPr/>
         </p:nvSpPr>
         <p:spPr>
           <a:xfrm>
-            <a:off x="4206240" y="3858768"/>
-            <a:ext cx="4343400" cy="731520"/>
+            <a:off x="5394960" y="3566160"/>
+            <a:ext cx="3108960" cy="457200"/>
           </a:xfrm>
           <a:prstGeom prst="rect">
             <a:avLst/>
@@ -2251,25 +2689,53 @@
               <a:buNone/>
             </a:pPr>
             <a:r>
-              <a:rPr lang="en-US" sz="1300" b="1" dirty="0">
+              <a:rPr lang="en-US" sz="2600" b="1" dirty="0">
                 <a:solidFill>
-                  <a:schemeClr val="tx2"/>
+                  <a:schemeClr val="accent1"/>
                 </a:solidFill>
+                <a:latin typeface="Cambria" pitchFamily="34" charset="0"/>
+                <a:ea typeface="Cambria" pitchFamily="34" charset="-122"/>
+                <a:cs typeface="Cambria" pitchFamily="34" charset="-120"/>
               </a:rPr>
-              <a:t>El tráfico orgánico de Warp vale ~US$155K/mes en pauta. </a:t>
+              <a:t>20% vs 5,6%</a:t>
             </a:r>
+            <a:endParaRPr lang="en-US" sz="2600" dirty="0"/>
+          </a:p>
+        </p:txBody>
+      </p:sp>
+      <p:sp>
+        <p:nvSpPr>
+          <p:cNvPr id="14" name="stat-label-3"/>
+          <p:cNvSpPr txBox="1"/>
+          <p:nvPr/>
+        </p:nvSpPr>
+        <p:spPr>
+          <a:xfrm>
+            <a:off x="5394960" y="4023360"/>
+            <a:ext cx="3154680" cy="502920"/>
+          </a:xfrm>
+          <a:prstGeom prst="rect">
+            <a:avLst/>
+          </a:prstGeom>
+          <a:noFill/>
+          <a:ln/>
+        </p:spPr>
+        <p:txBody>
+          <a:bodyPr wrap="square" lIns="0" tIns="0" rIns="0" bIns="0" rtlCol="0" anchor="t"/>
+          <a:lstStyle/>
+          <a:p>
             <a:pPr indent="0" marL="0">
               <a:buNone/>
             </a:pPr>
             <a:r>
-              <a:rPr lang="en-US" sz="1300" dirty="0">
+              <a:rPr lang="en-US" sz="1200" dirty="0">
                 <a:solidFill>
                   <a:schemeClr val="tx1"/>
                 </a:solidFill>
               </a:rPr>
-              <a:t>El nuestro, ~US$18K. Ellos reciben gratis lo que a nosotros nos costaría comprar.</a:t>
+              <a:t>de los leads calificados se vuelven clientes: orgánico vs. pauta</a:t>
             </a:r>
-            <a:endParaRPr lang="en-US" sz="1300" dirty="0"/>
+            <a:endParaRPr lang="en-US" sz="1200" dirty="0"/>
           </a:p>
         </p:txBody>
       </p:sp>
@@ -2378,7 +2844,7 @@
                 <a:ea typeface="Cambria" pitchFamily="34" charset="-122"/>
                 <a:cs typeface="Cambria" pitchFamily="34" charset="-120"/>
               </a:rPr>
-              <a:t>Pedimos US$166K, más US$24K atados a resultados</a:t>
+              <a:t>2027: US$52K con la pauta rediseñada</a:t>
             </a:r>
             <a:endParaRPr lang="en-US" sz="2600" dirty="0"/>
           </a:p>
@@ -2392,7 +2858,7 @@
         </p:nvGraphicFramePr>
         <p:xfrm>
           <a:off x="365760" y="1005840"/>
-          <a:ext cx="3566160" cy="2743200"/>
+          <a:ext cx="3383280" cy="2743200"/>
         </p:xfrm>
         <a:graphic xmlns:a="http://schemas.openxmlformats.org/drawingml/2006/main">
           <a:graphicData uri="http://schemas.openxmlformats.org/drawingml/2006/chart">
@@ -2408,7 +2874,7 @@
         </p:nvSpPr>
         <p:spPr>
           <a:xfrm>
-            <a:off x="1234440" y="1783080"/>
+            <a:off x="1143000" y="1783080"/>
             <a:ext cx="1828800" cy="685800"/>
           </a:xfrm>
           <a:prstGeom prst="rect">
@@ -2430,7 +2896,7 @@
                   <a:schemeClr val="tx2"/>
                 </a:solidFill>
               </a:rPr>
-              <a:t>US$166K</a:t>
+              <a:t>US$52K</a:t>
             </a:r>
             <a:endParaRPr lang="en-US" sz="2000" dirty="0"/>
           </a:p>
@@ -2444,7 +2910,7 @@
                   <a:schemeClr val="accent3"/>
                 </a:solidFill>
               </a:rPr>
-              <a:t>base anual</a:t>
+              <a:t>total 2027</a:t>
             </a:r>
             <a:endParaRPr lang="en-US" sz="2000" dirty="0"/>
           </a:p>
@@ -2465,19 +2931,19 @@
           </p:nvPr>
         </p:nvGraphicFramePr>
         <p:xfrm>
-          <a:off x="4206240" y="1005840"/>
-          <a:ext cx="4480560" cy="914400"/>
+          <a:off x="4023360" y="1005840"/>
+          <a:ext cx="4663440" cy="914400"/>
         </p:xfrm>
         <a:graphic>
           <a:graphicData uri="http://schemas.openxmlformats.org/drawingml/2006/table">
             <a:tbl>
               <a:tblPr/>
               <a:tblGrid>
-                <a:gridCol w="1051560"/>
-                <a:gridCol w="777240"/>
-                <a:gridCol w="2651760"/>
+                <a:gridCol w="960120"/>
+                <a:gridCol w="731520"/>
+                <a:gridCol w="2971800"/>
               </a:tblGrid>
-              <a:tr h="566928">
+              <a:tr h="658368">
                 <a:tc>
                   <a:txBody>
                     <a:bodyPr/>
@@ -2492,7 +2958,7 @@
                             <a:srgbClr val="1B3A52"/>
                           </a:solidFill>
                         </a:rPr>
-                        <a:t>Pauta digital</a:t>
+                        <a:t>Pauta</a:t>
                       </a:r>
                       <a:endParaRPr lang="en-US" sz="1200" dirty="0"/>
                     </a:p>
@@ -2532,7 +2998,7 @@
                             <a:srgbClr val="1B3A52"/>
                           </a:solidFill>
                         </a:rPr>
-                        <a:t>US$96K</a:t>
+                        <a:t>US$24K</a:t>
                       </a:r>
                       <a:endParaRPr lang="en-US" sz="1200" dirty="0"/>
                     </a:p>
@@ -2567,14 +3033,14 @@
                         <a:buNone/>
                       </a:pPr>
                       <a:r>
-                        <a:rPr lang="en-US" sz="1100" dirty="0">
+                        <a:rPr lang="en-US" sz="1050" dirty="0">
                           <a:solidFill>
                             <a:srgbClr val="13202A"/>
                           </a:solidFill>
                         </a:rPr>
-                        <a:t>US$8K/mes: Google de nicho (EE. UU. y México), LinkedIn a cuentas objetivo, Microsoft Ads, remarketing</a:t>
+                        <a:t>Google de nicho EE. UU. (45%) y México en español (15%), LinkedIn a cuentas objetivo (20%), remarketing (10%), awareness (10%). Meta solo remarketing</a:t>
                       </a:r>
-                      <a:endParaRPr lang="en-US" sz="1100" dirty="0"/>
+                      <a:endParaRPr lang="en-US" sz="1050" dirty="0"/>
                     </a:p>
                   </a:txBody>
                   <a:tcPr marL="50800" marR="50800" marT="38100" marB="38100" anchor="ctr">
@@ -2599,7 +3065,7 @@
                   </a:tcPr>
                 </a:tc>
               </a:tr>
-              <a:tr h="566928">
+              <a:tr h="658368">
                 <a:tc>
                   <a:txBody>
                     <a:bodyPr/>
@@ -2654,7 +3120,7 @@
                             <a:srgbClr val="1B3A52"/>
                           </a:solidFill>
                         </a:rPr>
-                        <a:t>US$60K</a:t>
+                        <a:t>US$22K</a:t>
                       </a:r>
                       <a:endParaRPr lang="en-US" sz="1200" dirty="0"/>
                     </a:p>
@@ -2689,14 +3155,14 @@
                         <a:buNone/>
                       </a:pPr>
                       <a:r>
-                        <a:rPr lang="en-US" sz="1100" dirty="0">
+                        <a:rPr lang="en-US" sz="1050" dirty="0">
                           <a:solidFill>
                             <a:srgbClr val="13202A"/>
                           </a:solidFill>
                         </a:rPr>
-                        <a:t>Landings de forwarders, brokers y Magaya; sitio en español; calculadoras; canal de YouTube</a:t>
+                        <a:t>Arreglos técnicos, landings de forwarders, brokers y Magaya, páginas en español, 6–8 videos de YouTube, directorios y reseñas</a:t>
                       </a:r>
-                      <a:endParaRPr lang="en-US" sz="1100" dirty="0"/>
+                      <a:endParaRPr lang="en-US" sz="1050" dirty="0"/>
                     </a:p>
                   </a:txBody>
                   <a:tcPr marL="50800" marR="50800" marT="38100" marB="38100" anchor="ctr">
@@ -2721,7 +3187,7 @@
                   </a:tcPr>
                 </a:tc>
               </a:tr>
-              <a:tr h="566928">
+              <a:tr h="658368">
                 <a:tc>
                   <a:txBody>
                     <a:bodyPr/>
@@ -2776,7 +3242,7 @@
                             <a:srgbClr val="1B3A52"/>
                           </a:solidFill>
                         </a:rPr>
-                        <a:t>US$10K</a:t>
+                        <a:t>US$6K</a:t>
                       </a:r>
                       <a:endParaRPr lang="en-US" sz="1200" dirty="0"/>
                     </a:p>
@@ -2811,136 +3277,14 @@
                         <a:buNone/>
                       </a:pPr>
                       <a:r>
-                        <a:rPr lang="en-US" sz="1100" dirty="0">
+                        <a:rPr lang="en-US" sz="1050" dirty="0">
                           <a:solidFill>
                             <a:srgbClr val="13202A"/>
                           </a:solidFill>
                         </a:rPr>
-                        <a:t>Datos SEO, monitoreo de anuncios de la competencia y medición hasta el primer envío</a:t>
+                        <a:t>Datos SEO y de IA, monitoreo de anuncios de la competencia, medición hasta el primer envío</a:t>
                       </a:r>
-                      <a:endParaRPr lang="en-US" sz="1100" dirty="0"/>
-                    </a:p>
-                  </a:txBody>
-                  <a:tcPr marL="50800" marR="50800" marT="38100" marB="38100" anchor="ctr">
-                    <a:lnL w="0" cap="flat" cmpd="sng" algn="ctr">
-                      <a:noFill/>
-                    </a:lnL>
-                    <a:lnR w="0" cap="flat" cmpd="sng" algn="ctr">
-                      <a:noFill/>
-                    </a:lnR>
-                    <a:lnT w="0" cap="flat" cmpd="sng" algn="ctr">
-                      <a:noFill/>
-                    </a:lnT>
-                    <a:lnB w="9525" cap="flat" cmpd="sng" algn="ctr">
-                      <a:solidFill>
-                        <a:srgbClr val="D6DCE0"/>
-                      </a:solidFill>
-                      <a:prstDash val="solid"/>
-                      <a:round/>
-                      <a:headEnd type="none" w="med" len="med"/>
-                      <a:tailEnd type="none" w="med" len="med"/>
-                    </a:lnB>
-                  </a:tcPr>
-                </a:tc>
-              </a:tr>
-              <a:tr h="566928">
-                <a:tc>
-                  <a:txBody>
-                    <a:bodyPr/>
-                    <a:lstStyle/>
-                    <a:p>
-                      <a:pPr indent="0" marL="0">
-                        <a:buNone/>
-                      </a:pPr>
-                      <a:r>
-                        <a:rPr lang="en-US" sz="1200" b="1" dirty="0">
-                          <a:solidFill>
-                            <a:srgbClr val="D9701A"/>
-                          </a:solidFill>
-                        </a:rPr>
-                        <a:t>Reserva</a:t>
-                      </a:r>
-                      <a:endParaRPr lang="en-US" sz="1200" dirty="0"/>
-                    </a:p>
-                  </a:txBody>
-                  <a:tcPr marL="50800" marR="50800" marT="38100" marB="38100" anchor="ctr">
-                    <a:lnL w="0" cap="flat" cmpd="sng" algn="ctr">
-                      <a:noFill/>
-                    </a:lnL>
-                    <a:lnR w="0" cap="flat" cmpd="sng" algn="ctr">
-                      <a:noFill/>
-                    </a:lnR>
-                    <a:lnT w="0" cap="flat" cmpd="sng" algn="ctr">
-                      <a:noFill/>
-                    </a:lnT>
-                    <a:lnB w="9525" cap="flat" cmpd="sng" algn="ctr">
-                      <a:solidFill>
-                        <a:srgbClr val="D6DCE0"/>
-                      </a:solidFill>
-                      <a:prstDash val="solid"/>
-                      <a:round/>
-                      <a:headEnd type="none" w="med" len="med"/>
-                      <a:tailEnd type="none" w="med" len="med"/>
-                    </a:lnB>
-                  </a:tcPr>
-                </a:tc>
-                <a:tc>
-                  <a:txBody>
-                    <a:bodyPr/>
-                    <a:lstStyle/>
-                    <a:p>
-                      <a:pPr indent="0" marL="0">
-                        <a:buNone/>
-                      </a:pPr>
-                      <a:r>
-                        <a:rPr lang="en-US" sz="1200" b="1" dirty="0">
-                          <a:solidFill>
-                            <a:srgbClr val="D9701A"/>
-                          </a:solidFill>
-                        </a:rPr>
-                        <a:t>US$24K</a:t>
-                      </a:r>
-                      <a:endParaRPr lang="en-US" sz="1200" dirty="0"/>
-                    </a:p>
-                  </a:txBody>
-                  <a:tcPr marL="50800" marR="50800" marT="38100" marB="38100" anchor="ctr">
-                    <a:lnL w="0" cap="flat" cmpd="sng" algn="ctr">
-                      <a:noFill/>
-                    </a:lnL>
-                    <a:lnR w="0" cap="flat" cmpd="sng" algn="ctr">
-                      <a:noFill/>
-                    </a:lnR>
-                    <a:lnT w="0" cap="flat" cmpd="sng" algn="ctr">
-                      <a:noFill/>
-                    </a:lnT>
-                    <a:lnB w="9525" cap="flat" cmpd="sng" algn="ctr">
-                      <a:solidFill>
-                        <a:srgbClr val="D6DCE0"/>
-                      </a:solidFill>
-                      <a:prstDash val="solid"/>
-                      <a:round/>
-                      <a:headEnd type="none" w="med" len="med"/>
-                      <a:tailEnd type="none" w="med" len="med"/>
-                    </a:lnB>
-                  </a:tcPr>
-                </a:tc>
-                <a:tc>
-                  <a:txBody>
-                    <a:bodyPr/>
-                    <a:lstStyle/>
-                    <a:p>
-                      <a:pPr indent="0" marL="0">
-                        <a:buNone/>
-                      </a:pPr>
-                      <a:r>
-                        <a:rPr lang="en-US" sz="1100" dirty="0">
-                          <a:solidFill>
-                            <a:srgbClr val="D9701A"/>
-                          </a:solidFill>
-                        </a:rPr>
-                        <a:t>Solo se libera si el piloto cumple la meta de costo por cuenta activada</a:t>
-                      </a:r>
-                      <a:endParaRPr lang="en-US" sz="1100" dirty="0"/>
+                      <a:endParaRPr lang="en-US" sz="1050" dirty="0"/>
                     </a:p>
                   </a:txBody>
                   <a:tcPr marL="50800" marR="50800" marT="38100" marB="38100" anchor="ctr">
@@ -2971,14 +3315,14 @@
       </p:graphicFrame>
       <p:sp>
         <p:nvSpPr>
-          <p:cNvPr id="6" name="card-how"/>
+          <p:cNvPr id="6" name="card-rules"/>
           <p:cNvSpPr/>
           <p:nvPr/>
         </p:nvSpPr>
         <p:spPr>
           <a:xfrm>
-            <a:off x="4206240" y="3429000"/>
-            <a:ext cx="4480560" cy="1234440"/>
+            <a:off x="4023360" y="3108960"/>
+            <a:ext cx="4663440" cy="1280160"/>
           </a:xfrm>
           <a:prstGeom prst="rect">
             <a:avLst/>
@@ -2996,14 +3340,14 @@
       </p:sp>
       <p:sp>
         <p:nvSpPr>
-          <p:cNvPr id="7" name="text-how"/>
+          <p:cNvPr id="7" name="text-rules"/>
           <p:cNvSpPr txBox="1"/>
           <p:nvPr/>
         </p:nvSpPr>
         <p:spPr>
           <a:xfrm>
-            <a:off x="4343400" y="3474720"/>
-            <a:ext cx="4251960" cy="1143000"/>
+            <a:off x="4160520" y="3172968"/>
+            <a:ext cx="4434840" cy="1188720"/>
           </a:xfrm>
           <a:prstGeom prst="rect">
             <a:avLst/>
@@ -3027,7 +3371,7 @@
                   <a:schemeClr val="tx2"/>
                 </a:solidFill>
               </a:rPr>
-              <a:t>Cómo lo invertimos</a:t>
+              <a:t>Reglas para que la pauta sí se pague</a:t>
             </a:r>
             <a:endParaRPr lang="en-US" sz="1100" dirty="0"/>
           </a:p>
@@ -3045,7 +3389,7 @@
                   <a:schemeClr val="tx1"/>
                 </a:solidFill>
               </a:rPr>
-              <a:t>Primero 90 días de piloto, con la casa en orden y la medición lista.</a:t>
+              <a:t>Se libera por trimestre: US$5K, 6K, 6,5K y 6,5K.</a:t>
             </a:r>
             <a:endParaRPr lang="en-US" sz="1100" dirty="0"/>
           </a:p>
@@ -3063,7 +3407,7 @@
                   <a:schemeClr val="tx1"/>
                 </a:solidFill>
               </a:rPr>
-              <a:t>Cada canal se escala o se corta según su costo por cuenta que hace su primer envío.</a:t>
+              <a:t>Meta: costo por cliente ≤ US$5K (2026: US$15K) y 12% de calificados que cierran (2026: 5,6%).</a:t>
             </a:r>
             <a:endParaRPr lang="en-US" sz="1100" dirty="0"/>
           </a:p>
@@ -3081,7 +3425,7 @@
                   <a:schemeClr val="tx1"/>
                 </a:solidFill>
               </a:rPr>
-              <a:t>No competimos por "LTL quote" (US$30,64 por clic): vamos al nicho y a México (US$2,94).</a:t>
+              <a:t>Si al cierre del Q2 el costo por cliente supera US$8K, el saldo pasa a SEO + GEO.</a:t>
             </a:r>
             <a:endParaRPr lang="en-US" sz="1100" dirty="0"/>
           </a:p>
@@ -3192,22 +3536,38 @@
                 <a:ea typeface="Cambria" pitchFamily="34" charset="-122"/>
                 <a:cs typeface="Cambria" pitchFamily="34" charset="-120"/>
               </a:rPr>
-              <a:t>Si no ocupamos este espacio en 2027, lo ocupará otro</a:t>
+              <a:t>Meta 2027: de US$97K a US$130–150K</a:t>
             </a:r>
             <a:endParaRPr lang="en-US" sz="2600" dirty="0"/>
           </a:p>
         </p:txBody>
       </p:sp>
-      <p:sp>
-        <p:nvSpPr>
-          <p:cNvPr id="3" name="col-gain"/>
+      <p:graphicFrame>
+        <p:nvGraphicFramePr>
+          <p:cNvPr id="3" name="chart-revenue" descr=""/>
+          <p:cNvGraphicFramePr/>
+          <p:nvPr/>
+        </p:nvGraphicFramePr>
+        <p:xfrm>
+          <a:off x="365760" y="1005840"/>
+          <a:ext cx="4206240" cy="3611880"/>
+        </p:xfrm>
+        <a:graphic xmlns:a="http://schemas.openxmlformats.org/drawingml/2006/main">
+          <a:graphicData uri="http://schemas.openxmlformats.org/drawingml/2006/chart">
+            <c:chart xmlns:c="http://schemas.openxmlformats.org/drawingml/2006/chart" r:id="rId1"/>
+          </a:graphicData>
+        </a:graphic>
+      </p:graphicFrame>
+      <p:sp>
+        <p:nvSpPr>
+          <p:cNvPr id="4" name="card-gain-lose"/>
           <p:cNvSpPr/>
           <p:nvPr/>
         </p:nvSpPr>
         <p:spPr>
           <a:xfrm>
-            <a:off x="457200" y="1051560"/>
-            <a:ext cx="3977640" cy="2514600"/>
+            <a:off x="4846320" y="1005840"/>
+            <a:ext cx="3840480" cy="1783080"/>
           </a:xfrm>
           <a:prstGeom prst="rect">
             <a:avLst/>
@@ -3225,14 +3585,104 @@
       </p:sp>
       <p:sp>
         <p:nvSpPr>
-          <p:cNvPr id="4" name="col-gain-title"/>
+          <p:cNvPr id="5" name="text-gain-lose"/>
           <p:cNvSpPr txBox="1"/>
           <p:nvPr/>
         </p:nvSpPr>
         <p:spPr>
           <a:xfrm>
-            <a:off x="640080" y="1143000"/>
-            <a:ext cx="3611880" cy="365760"/>
+            <a:off x="4983480" y="1069848"/>
+            <a:ext cx="3611880" cy="1664208"/>
+          </a:xfrm>
+          <a:prstGeom prst="rect">
+            <a:avLst/>
+          </a:prstGeom>
+          <a:noFill/>
+          <a:ln/>
+        </p:spPr>
+        <p:txBody>
+          <a:bodyPr wrap="square" lIns="0" tIns="0" rIns="0" bIns="0" rtlCol="0" anchor="t"/>
+          <a:lstStyle/>
+          <a:p>
+            <a:pPr indent="0" marL="0">
+              <a:spcAft>
+                <a:spcPts val="300"/>
+              </a:spcAft>
+              <a:buNone/>
+            </a:pPr>
+            <a:r>
+              <a:rPr lang="en-US" sz="1300" b="1" dirty="0">
+                <a:solidFill>
+                  <a:schemeClr val="accent4"/>
+                </a:solidFill>
+              </a:rPr>
+              <a:t>Lo que ganamos</a:t>
+            </a:r>
+            <a:endParaRPr lang="en-US" sz="1150" dirty="0"/>
+          </a:p>
+          <a:p>
+            <a:pPr indent="0" marL="0">
+              <a:spcAft>
+                <a:spcPts val="300"/>
+              </a:spcAft>
+              <a:buNone/>
+            </a:pPr>
+            <a:r>
+              <a:rPr lang="en-US" sz="1150" dirty="0">
+                <a:solidFill>
+                  <a:schemeClr val="tx1"/>
+                </a:solidFill>
+              </a:rPr>
+              <a:t>Clientes de quien aún no nos conoce: forwarders, brokers y exportadores mexicanos.</a:t>
+            </a:r>
+            <a:endParaRPr lang="en-US" sz="1150" dirty="0"/>
+          </a:p>
+          <a:p>
+            <a:pPr indent="0" marL="0">
+              <a:spcAft>
+                <a:spcPts val="300"/>
+              </a:spcAft>
+              <a:buNone/>
+            </a:pPr>
+            <a:r>
+              <a:rPr lang="en-US" sz="1300" b="1" dirty="0">
+                <a:solidFill>
+                  <a:schemeClr val="accent5"/>
+                </a:solidFill>
+              </a:rPr>
+              <a:t>Lo que perdemos si no lo hacemos</a:t>
+            </a:r>
+            <a:endParaRPr lang="en-US" sz="1150" dirty="0"/>
+          </a:p>
+          <a:p>
+            <a:pPr indent="0" marL="0">
+              <a:spcAft>
+                <a:spcPts val="300"/>
+              </a:spcAft>
+              <a:buNone/>
+            </a:pPr>
+            <a:r>
+              <a:rPr lang="en-US" sz="1150" dirty="0">
+                <a:solidFill>
+                  <a:schemeClr val="tx1"/>
+                </a:solidFill>
+              </a:rPr>
+              <a:t>Seguimos dependiendo de la marca y los referidos, mientras Warp, Go Freight y ExFreight son la respuesta por defecto en Google y en la IA.</a:t>
+            </a:r>
+            <a:endParaRPr lang="en-US" sz="1150" dirty="0"/>
+          </a:p>
+        </p:txBody>
+      </p:sp>
+      <p:sp>
+        <p:nvSpPr>
+          <p:cNvPr id="6" name="kpi-num-1"/>
+          <p:cNvSpPr txBox="1"/>
+          <p:nvPr/>
+        </p:nvSpPr>
+        <p:spPr>
+          <a:xfrm>
+            <a:off x="4846320" y="2971800"/>
+            <a:ext cx="1828800" cy="411480"/>
           </a:xfrm>
           <a:prstGeom prst="rect">
             <a:avLst/>
@@ -3248,30 +3698,30 @@
               <a:buNone/>
             </a:pPr>
             <a:r>
-              <a:rPr lang="en-US" sz="1600" b="1" dirty="0">
+              <a:rPr lang="en-US" sz="2200" b="1" dirty="0">
                 <a:solidFill>
-                  <a:schemeClr val="accent4"/>
+                  <a:schemeClr val="accent1"/>
                 </a:solidFill>
                 <a:latin typeface="Cambria" pitchFamily="34" charset="0"/>
                 <a:ea typeface="Cambria" pitchFamily="34" charset="-122"/>
                 <a:cs typeface="Cambria" pitchFamily="34" charset="-120"/>
               </a:rPr>
-              <a:t>Lo que ganamos</a:t>
+              <a:t>~30</a:t>
             </a:r>
-            <a:endParaRPr lang="en-US" sz="1600" dirty="0"/>
+            <a:endParaRPr lang="en-US" sz="2200" dirty="0"/>
           </a:p>
         </p:txBody>
       </p:sp>
       <p:sp>
         <p:nvSpPr>
-          <p:cNvPr id="5" name="col-gain-list"/>
+          <p:cNvPr id="7" name="kpi-label-1"/>
           <p:cNvSpPr txBox="1"/>
           <p:nvPr/>
         </p:nvSpPr>
         <p:spPr>
           <a:xfrm>
-            <a:off x="640080" y="1572768"/>
-            <a:ext cx="3611880" cy="1920240"/>
+            <a:off x="4846320" y="3383280"/>
+            <a:ext cx="1828800" cy="365760"/>
           </a:xfrm>
           <a:prstGeom prst="rect">
             <a:avLst/>
@@ -3283,114 +3733,31 @@
           <a:bodyPr wrap="square" lIns="0" tIns="0" rIns="0" bIns="0" rtlCol="0" anchor="t"/>
           <a:lstStyle/>
           <a:p>
-            <a:pPr marL="342900" indent="-342900">
-              <a:spcAft>
-                <a:spcPts val="500"/>
-              </a:spcAft>
-              <a:buSzPct val="100000"/>
-              <a:buChar char="•"/>
+            <a:pPr indent="0" marL="0">
+              <a:buNone/>
             </a:pPr>
             <a:r>
-              <a:rPr lang="en-US" sz="1200" dirty="0">
+              <a:rPr lang="en-US" sz="1100" dirty="0">
                 <a:solidFill>
                   <a:schemeClr val="tx1"/>
                 </a:solidFill>
               </a:rPr>
-              <a:t>Ser la respuesta de Google y la IA a "LTL para forwarders y brokers" y al cruce a México</a:t>
+              <a:t>clientes nuevos (2026: 19)</a:t>
             </a:r>
-            <a:endParaRPr lang="en-US" sz="1200" dirty="0"/>
-          </a:p>
-          <a:p>
-            <a:pPr marL="342900" indent="-342900">
-              <a:spcAft>
-                <a:spcPts val="500"/>
-              </a:spcAft>
-              <a:buSzPct val="100000"/>
-              <a:buChar char="•"/>
-            </a:pPr>
-            <a:r>
-              <a:rPr lang="en-US" sz="1200" dirty="0">
-                <a:solidFill>
-                  <a:schemeClr val="tx1"/>
-                </a:solidFill>
-              </a:rPr>
-              <a:t>Leads de forwarders, brokers y exportadores mexicanos, con clics 5–10 veces más baratos en México</a:t>
-            </a:r>
-            <a:endParaRPr lang="en-US" sz="1200" dirty="0"/>
-          </a:p>
-          <a:p>
-            <a:pPr marL="342900" indent="-342900">
-              <a:spcAft>
-                <a:spcPts val="500"/>
-              </a:spcAft>
-              <a:buSzPct val="100000"/>
-              <a:buChar char="•"/>
-            </a:pPr>
-            <a:r>
-              <a:rPr lang="en-US" sz="1200" dirty="0">
-                <a:solidFill>
-                  <a:schemeClr val="tx1"/>
-                </a:solidFill>
-              </a:rPr>
-              <a:t>Un activo propio que sigue trayendo clientes cuando apagamos la pauta</a:t>
-            </a:r>
-            <a:endParaRPr lang="en-US" sz="1200" dirty="0"/>
-          </a:p>
-          <a:p>
-            <a:pPr marL="342900" indent="-342900">
-              <a:spcAft>
-                <a:spcPts val="500"/>
-              </a:spcAft>
-              <a:buSzPct val="100000"/>
-              <a:buChar char="•"/>
-            </a:pPr>
-            <a:r>
-              <a:rPr lang="en-US" sz="1200" dirty="0">
-                <a:solidFill>
-                  <a:schemeClr val="tx1"/>
-                </a:solidFill>
-              </a:rPr>
-              <a:t>Llegar antes a un corredor que creció 29,8% en camión (ago 2026)</a:t>
-            </a:r>
-            <a:endParaRPr lang="en-US" sz="1200" dirty="0"/>
+            <a:endParaRPr lang="en-US" sz="1100" dirty="0"/>
           </a:p>
         </p:txBody>
       </p:sp>
       <p:sp>
         <p:nvSpPr>
-          <p:cNvPr id="6" name="col-lose"/>
-          <p:cNvSpPr/>
+          <p:cNvPr id="8" name="kpi-num-2"/>
+          <p:cNvSpPr txBox="1"/>
           <p:nvPr/>
         </p:nvSpPr>
         <p:spPr>
           <a:xfrm>
-            <a:off x="4709160" y="1051560"/>
-            <a:ext cx="3977640" cy="2514600"/>
-          </a:xfrm>
-          <a:prstGeom prst="rect">
-            <a:avLst/>
-          </a:prstGeom>
-          <a:solidFill>
-            <a:schemeClr val="bg2"/>
-          </a:solidFill>
-          <a:ln w="12700">
-            <a:solidFill>
-              <a:schemeClr val="bg2"/>
-            </a:solidFill>
-            <a:prstDash val="solid"/>
-          </a:ln>
-        </p:spPr>
-      </p:sp>
-      <p:sp>
-        <p:nvSpPr>
-          <p:cNvPr id="7" name="col-lose-title"/>
-          <p:cNvSpPr txBox="1"/>
-          <p:nvPr/>
-        </p:nvSpPr>
-        <p:spPr>
-          <a:xfrm>
-            <a:off x="4892040" y="1143000"/>
-            <a:ext cx="3611880" cy="365760"/>
+            <a:off x="6812280" y="2971800"/>
+            <a:ext cx="1828800" cy="411480"/>
           </a:xfrm>
           <a:prstGeom prst="rect">
             <a:avLst/>
@@ -3406,30 +3773,30 @@
               <a:buNone/>
             </a:pPr>
             <a:r>
-              <a:rPr lang="en-US" sz="1600" b="1" dirty="0">
+              <a:rPr lang="en-US" sz="2200" b="1" dirty="0">
                 <a:solidFill>
-                  <a:schemeClr val="accent5"/>
+                  <a:schemeClr val="accent1"/>
                 </a:solidFill>
                 <a:latin typeface="Cambria" pitchFamily="34" charset="0"/>
                 <a:ea typeface="Cambria" pitchFamily="34" charset="-122"/>
                 <a:cs typeface="Cambria" pitchFamily="34" charset="-120"/>
               </a:rPr>
-              <a:t>Lo que perdemos si no lo hacemos</a:t>
+              <a:t>≤US$5K</a:t>
             </a:r>
-            <a:endParaRPr lang="en-US" sz="1600" dirty="0"/>
+            <a:endParaRPr lang="en-US" sz="2200" dirty="0"/>
           </a:p>
         </p:txBody>
       </p:sp>
       <p:sp>
         <p:nvSpPr>
-          <p:cNvPr id="8" name="col-lose-list"/>
+          <p:cNvPr id="9" name="kpi-label-2"/>
           <p:cNvSpPr txBox="1"/>
           <p:nvPr/>
         </p:nvSpPr>
         <p:spPr>
           <a:xfrm>
-            <a:off x="4892040" y="1572768"/>
-            <a:ext cx="3611880" cy="1920240"/>
+            <a:off x="6812280" y="3383280"/>
+            <a:ext cx="1828800" cy="365760"/>
           </a:xfrm>
           <a:prstGeom prst="rect">
             <a:avLst/>
@@ -3441,89 +3808,31 @@
           <a:bodyPr wrap="square" lIns="0" tIns="0" rIns="0" bIns="0" rtlCol="0" anchor="t"/>
           <a:lstStyle/>
           <a:p>
-            <a:pPr marL="342900" indent="-342900">
-              <a:spcAft>
-                <a:spcPts val="500"/>
-              </a:spcAft>
-              <a:buSzPct val="100000"/>
-              <a:buChar char="•"/>
+            <a:pPr indent="0" marL="0">
+              <a:buNone/>
             </a:pPr>
             <a:r>
-              <a:rPr lang="en-US" sz="1200" dirty="0">
+              <a:rPr lang="en-US" sz="1100" dirty="0">
                 <a:solidFill>
                   <a:schemeClr val="tx1"/>
                 </a:solidFill>
               </a:rPr>
-              <a:t>Warp, Go Freight y ExFreight siguen siendo la respuesta por defecto</a:t>
+              <a:t>costo por cliente en pauta</a:t>
             </a:r>
-            <a:endParaRPr lang="en-US" sz="1200" dirty="0"/>
-          </a:p>
-          <a:p>
-            <a:pPr marL="342900" indent="-342900">
-              <a:spcAft>
-                <a:spcPts val="500"/>
-              </a:spcAft>
-              <a:buSzPct val="100000"/>
-              <a:buChar char="•"/>
-            </a:pPr>
-            <a:r>
-              <a:rPr lang="en-US" sz="1200" dirty="0">
-                <a:solidFill>
-                  <a:schemeClr val="tx1"/>
-                </a:solidFill>
-              </a:rPr>
-              <a:t>Nuestra ventaja con Magaya se diluye cuando otros se integren</a:t>
-            </a:r>
-            <a:endParaRPr lang="en-US" sz="1200" dirty="0"/>
-          </a:p>
-          <a:p>
-            <a:pPr marL="342900" indent="-342900">
-              <a:spcAft>
-                <a:spcPts val="500"/>
-              </a:spcAft>
-              <a:buSzPct val="100000"/>
-              <a:buChar char="•"/>
-            </a:pPr>
-            <a:r>
-              <a:rPr lang="en-US" sz="1200" dirty="0">
-                <a:solidFill>
-                  <a:schemeClr val="tx1"/>
-                </a:solidFill>
-              </a:rPr>
-              <a:t>Seguimos dependiendo solo de ventas directas y del boca a boca</a:t>
-            </a:r>
-            <a:endParaRPr lang="en-US" sz="1200" dirty="0"/>
-          </a:p>
-          <a:p>
-            <a:pPr marL="342900" indent="-342900">
-              <a:spcAft>
-                <a:spcPts val="500"/>
-              </a:spcAft>
-              <a:buSzPct val="100000"/>
-              <a:buChar char="•"/>
-            </a:pPr>
-            <a:r>
-              <a:rPr lang="en-US" sz="1200" dirty="0">
-                <a:solidFill>
-                  <a:schemeClr val="tx1"/>
-                </a:solidFill>
-              </a:rPr>
-              <a:t>Los agentes de IA ya cotizan y reservan fletes: si no nos leen, no nos compran</a:t>
-            </a:r>
-            <a:endParaRPr lang="en-US" sz="1200" dirty="0"/>
+            <a:endParaRPr lang="en-US" sz="1100" dirty="0"/>
           </a:p>
         </p:txBody>
       </p:sp>
       <p:sp>
         <p:nvSpPr>
-          <p:cNvPr id="9" name="kpi-num-1"/>
+          <p:cNvPr id="10" name="kpi-num-3"/>
           <p:cNvSpPr txBox="1"/>
           <p:nvPr/>
         </p:nvSpPr>
         <p:spPr>
           <a:xfrm>
-            <a:off x="457200" y="3703320"/>
-            <a:ext cx="1920240" cy="457200"/>
+            <a:off x="4846320" y="3840480"/>
+            <a:ext cx="1828800" cy="411480"/>
           </a:xfrm>
           <a:prstGeom prst="rect">
             <a:avLst/>
@@ -3555,14 +3864,14 @@
       </p:sp>
       <p:sp>
         <p:nvSpPr>
-          <p:cNvPr id="10" name="kpi-label-1"/>
+          <p:cNvPr id="11" name="kpi-label-3"/>
           <p:cNvSpPr txBox="1"/>
           <p:nvPr/>
         </p:nvSpPr>
         <p:spPr>
           <a:xfrm>
-            <a:off x="457200" y="4160520"/>
-            <a:ext cx="1920240" cy="502920"/>
+            <a:off x="4846320" y="4251960"/>
+            <a:ext cx="1828800" cy="365760"/>
           </a:xfrm>
           <a:prstGeom prst="rect">
             <a:avLst/>
@@ -3583,7 +3892,7 @@
                   <a:schemeClr val="tx1"/>
                 </a:solidFill>
               </a:rPr>
-              <a:t>tráfico orgánico sin marca (hoy ~17%)</a:t>
+              <a:t>tráfico orgánico sin marca</a:t>
             </a:r>
             <a:endParaRPr lang="en-US" sz="1100" dirty="0"/>
           </a:p>
@@ -3591,14 +3900,14 @@
       </p:sp>
       <p:sp>
         <p:nvSpPr>
-          <p:cNvPr id="11" name="kpi-num-2"/>
+          <p:cNvPr id="12" name="kpi-num-4"/>
           <p:cNvSpPr txBox="1"/>
           <p:nvPr/>
         </p:nvSpPr>
         <p:spPr>
           <a:xfrm>
-            <a:off x="2532888" y="3703320"/>
-            <a:ext cx="1920240" cy="457200"/>
+            <a:off x="6812280" y="3840480"/>
+            <a:ext cx="1828800" cy="411480"/>
           </a:xfrm>
           <a:prstGeom prst="rect">
             <a:avLst/>
@@ -3630,14 +3939,14 @@
       </p:sp>
       <p:sp>
         <p:nvSpPr>
-          <p:cNvPr id="12" name="kpi-label-2"/>
+          <p:cNvPr id="13" name="kpi-label-4"/>
           <p:cNvSpPr txBox="1"/>
           <p:nvPr/>
         </p:nvSpPr>
         <p:spPr>
           <a:xfrm>
-            <a:off x="2532888" y="4160520"/>
-            <a:ext cx="1920240" cy="502920"/>
+            <a:off x="6812280" y="4251960"/>
+            <a:ext cx="1828800" cy="365760"/>
           </a:xfrm>
           <a:prstGeom prst="rect">
             <a:avLst/>
@@ -3659,156 +3968,6 @@
                 </a:solidFill>
               </a:rPr>
               <a:t>citas en la IA de Google</a:t>
-            </a:r>
-            <a:endParaRPr lang="en-US" sz="1100" dirty="0"/>
-          </a:p>
-        </p:txBody>
-      </p:sp>
-      <p:sp>
-        <p:nvSpPr>
-          <p:cNvPr id="13" name="kpi-num-3"/>
-          <p:cNvSpPr txBox="1"/>
-          <p:nvPr/>
-        </p:nvSpPr>
-        <p:spPr>
-          <a:xfrm>
-            <a:off x="4608576" y="3703320"/>
-            <a:ext cx="1920240" cy="457200"/>
-          </a:xfrm>
-          <a:prstGeom prst="rect">
-            <a:avLst/>
-          </a:prstGeom>
-          <a:noFill/>
-          <a:ln/>
-        </p:spPr>
-        <p:txBody>
-          <a:bodyPr wrap="square" lIns="0" tIns="0" rIns="0" bIns="0" rtlCol="0" anchor="ctr"/>
-          <a:lstStyle/>
-          <a:p>
-            <a:pPr indent="0" marL="0">
-              <a:buNone/>
-            </a:pPr>
-            <a:r>
-              <a:rPr lang="en-US" sz="2200" b="1" dirty="0">
-                <a:solidFill>
-                  <a:schemeClr val="accent1"/>
-                </a:solidFill>
-                <a:latin typeface="Cambria" pitchFamily="34" charset="0"/>
-                <a:ea typeface="Cambria" pitchFamily="34" charset="-122"/>
-                <a:cs typeface="Cambria" pitchFamily="34" charset="-120"/>
-              </a:rPr>
-              <a:t>5 de 8</a:t>
-            </a:r>
-            <a:endParaRPr lang="en-US" sz="2200" dirty="0"/>
-          </a:p>
-        </p:txBody>
-      </p:sp>
-      <p:sp>
-        <p:nvSpPr>
-          <p:cNvPr id="14" name="kpi-label-3"/>
-          <p:cNvSpPr txBox="1"/>
-          <p:nvPr/>
-        </p:nvSpPr>
-        <p:spPr>
-          <a:xfrm>
-            <a:off x="4608576" y="4160520"/>
-            <a:ext cx="1920240" cy="502920"/>
-          </a:xfrm>
-          <a:prstGeom prst="rect">
-            <a:avLst/>
-          </a:prstGeom>
-          <a:noFill/>
-          <a:ln/>
-        </p:spPr>
-        <p:txBody>
-          <a:bodyPr wrap="square" lIns="0" tIns="0" rIns="0" bIns="0" rtlCol="0" anchor="t"/>
-          <a:lstStyle/>
-          <a:p>
-            <a:pPr indent="0" marL="0">
-              <a:buNone/>
-            </a:pPr>
-            <a:r>
-              <a:rPr lang="en-US" sz="1100" dirty="0">
-                <a:solidFill>
-                  <a:schemeClr val="tx1"/>
-                </a:solidFill>
-              </a:rPr>
-              <a:t>preguntas de compradores donde aparecemos (hoy 3)</a:t>
-            </a:r>
-            <a:endParaRPr lang="en-US" sz="1100" dirty="0"/>
-          </a:p>
-        </p:txBody>
-      </p:sp>
-      <p:sp>
-        <p:nvSpPr>
-          <p:cNvPr id="15" name="kpi-num-4"/>
-          <p:cNvSpPr txBox="1"/>
-          <p:nvPr/>
-        </p:nvSpPr>
-        <p:spPr>
-          <a:xfrm>
-            <a:off x="6684264" y="3703320"/>
-            <a:ext cx="1920240" cy="457200"/>
-          </a:xfrm>
-          <a:prstGeom prst="rect">
-            <a:avLst/>
-          </a:prstGeom>
-          <a:noFill/>
-          <a:ln/>
-        </p:spPr>
-        <p:txBody>
-          <a:bodyPr wrap="square" lIns="0" tIns="0" rIns="0" bIns="0" rtlCol="0" anchor="ctr"/>
-          <a:lstStyle/>
-          <a:p>
-            <a:pPr indent="0" marL="0">
-              <a:buNone/>
-            </a:pPr>
-            <a:r>
-              <a:rPr lang="en-US" sz="2200" b="1" dirty="0">
-                <a:solidFill>
-                  <a:schemeClr val="accent1"/>
-                </a:solidFill>
-                <a:latin typeface="Cambria" pitchFamily="34" charset="0"/>
-                <a:ea typeface="Cambria" pitchFamily="34" charset="-122"/>
-                <a:cs typeface="Cambria" pitchFamily="34" charset="-120"/>
-              </a:rPr>
-              <a:t>90 días</a:t>
-            </a:r>
-            <a:endParaRPr lang="en-US" sz="2200" dirty="0"/>
-          </a:p>
-        </p:txBody>
-      </p:sp>
-      <p:sp>
-        <p:nvSpPr>
-          <p:cNvPr id="16" name="kpi-label-4"/>
-          <p:cNvSpPr txBox="1"/>
-          <p:nvPr/>
-        </p:nvSpPr>
-        <p:spPr>
-          <a:xfrm>
-            <a:off x="6684264" y="4160520"/>
-            <a:ext cx="1920240" cy="502920"/>
-          </a:xfrm>
-          <a:prstGeom prst="rect">
-            <a:avLst/>
-          </a:prstGeom>
-          <a:noFill/>
-          <a:ln/>
-        </p:spPr>
-        <p:txBody>
-          <a:bodyPr wrap="square" lIns="0" tIns="0" rIns="0" bIns="0" rtlCol="0" anchor="t"/>
-          <a:lstStyle/>
-          <a:p>
-            <a:pPr indent="0" marL="0">
-              <a:buNone/>
-            </a:pPr>
-            <a:r>
-              <a:rPr lang="en-US" sz="1100" dirty="0">
-                <a:solidFill>
-                  <a:schemeClr val="tx1"/>
-                </a:solidFill>
-              </a:rPr>
-              <a:t>para decidir: escalar o cortar</a:t>
             </a:r>
             <a:endParaRPr lang="en-US" sz="1100" dirty="0"/>
           </a:p>

</xml_diff>

<commit_message>
Align 2027 budget pitch with official figures (US$24K paid, COP 45M agency)
Co-Authored-By: Claude Opus 5.5 <noreply@anthropic.com>
Claude-Session: https://claude.ai/code/session_011mVvDzVJqJWuqDhVDGwPKG
</commit_message>
<xml_diff>
--- a/reports/GLT_Budget_Marketing_2027.pptx
+++ b/reports/GLT_Budget_Marketing_2027.pptx
@@ -109,17 +109,17 @@
   <p:extLst>
     <p:ext uri="{521415D9-36F7-43E2-AB2F-B90AF26B5E84}">
       <p14:sectionLst xmlns:p14="http://schemas.microsoft.com/office/powerpoint/2010/main">
-        <p14:section name="Resultados 2026" id="{721b4bfd-d695-663d-ae09-3a52d486643d}">
+        <p14:section name="Resultados 2026" id="{5ee896c5-15a9-12b5-2e83-81647452863a}">
           <p14:sldIdLst>
             <p14:sldId id="256"/>
           </p14:sldIdLst>
         </p14:section>
-        <p14:section name="Presupuesto 2027" id="{74981d6d-0172-9c38-c6f1-d3e22f32737a}">
+        <p14:section name="Presupuesto 2027" id="{fe2c549a-3a05-48db-8461-9abd57ec6d90}">
           <p14:sldIdLst>
             <p14:sldId id="257"/>
           </p14:sldIdLst>
         </p14:section>
-        <p14:section name="Metas 2027" id="{f8576777-8ecb-b9ef-16bc-77edb98d6e85}">
+        <p14:section name="Metas 2027" id="{4b4e1045-8a47-07b0-c75c-ba56eb8841fe}">
           <p14:sldIdLst>
             <p14:sldId id="258"/>
           </p14:sldIdLst>
@@ -499,11 +499,42 @@
   <c:date1904 val="0"/>
   <c:roundedCorners val="1"/>
   <c:chart>
-    <c:autoTitleDeleted val="1"/>
+    <c:title>
+      <c:tx>
+        <c:rich>
+          <a:bodyPr/>
+          <a:lstStyle/>
+          <a:p>
+            <a:pPr>
+              <a:defRPr sz="1200" b="0" i="0" u="none" strike="noStrike">
+                <a:solidFill>
+                  <a:srgbClr val="13202A"/>
+                </a:solidFill>
+                <a:latin typeface="+mn-lt"/>
+              </a:defRPr>
+            </a:pPr>
+            <a:r>
+              <a:rPr sz="1200" b="0" i="0" u="none" strike="noStrike">
+                <a:solidFill>
+                  <a:srgbClr val="13202A"/>
+                </a:solidFill>
+                <a:latin typeface="+mn-lt"/>
+              </a:rPr>
+              <a:t>Inversión de marketing digital (US$ miles)</a:t>
+            </a:r>
+          </a:p>
+        </c:rich>
+      </c:tx>
+      <c:layout/>
+      <c:overlay val="0"/>
+    </c:title>
+    <c:autoTitleDeleted val="0"/>
     <c:plotArea>
       <c:layout/>
-      <c:doughnutChart>
-        <c:varyColors val="1"/>
+      <c:barChart>
+        <c:barDir val="col"/>
+        <c:grouping val="stacked"/>
+        <c:varyColors val="0"/>
         <c:ser>
           <c:idx val="0"/>
           <c:order val="0"/>
@@ -513,191 +544,264 @@
               <c:strCache>
                 <c:ptCount val="1"/>
                 <c:pt idx="0">
-                  <c:v>Presupuesto 2027</c:v>
+                  <c:v>Pauta digital</c:v>
                 </c:pt>
               </c:strCache>
             </c:strRef>
           </c:tx>
           <c:spPr>
             <a:solidFill>
-              <a:schemeClr val="accent1"/>
+              <a:srgbClr val="D9701A"/>
             </a:solidFill>
-            <a:ln w="9525" cap="flat">
-              <a:solidFill>
-                <a:srgbClr val="F9F9F9"/>
-              </a:solidFill>
-              <a:prstDash val="solid"/>
-              <a:round/>
-            </a:ln>
             <a:effectLst/>
           </c:spPr>
-          <c:dPt>
-            <c:idx val="0"/>
-            <c:bubble3D val="0"/>
-            <c:spPr>
-              <a:solidFill>
-                <a:srgbClr val="D9701A"/>
-              </a:solidFill>
-              <a:effectLst/>
-            </c:spPr>
-          </c:dPt>
-          <c:dPt>
-            <c:idx val="1"/>
-            <c:bubble3D val="0"/>
-            <c:spPr>
-              <a:solidFill>
-                <a:srgbClr val="1B3A52"/>
-              </a:solidFill>
-              <a:effectLst/>
-            </c:spPr>
-          </c:dPt>
-          <c:dPt>
-            <c:idx val="2"/>
-            <c:bubble3D val="0"/>
-            <c:spPr>
-              <a:solidFill>
-                <a:srgbClr val="9FB3C4"/>
-              </a:solidFill>
-              <a:effectLst/>
-            </c:spPr>
-          </c:dPt>
+          <c:invertIfNegative val="0"/>
           <c:dLbls>
-            <c:dLbl>
-              <c:idx val="0"/>
-              <c:numFmt formatCode="0%" sourceLinked="0"/>
-              <c:spPr/>
-              <c:txPr>
-                <a:bodyPr/>
-                <a:lstStyle/>
-                <a:p>
-                  <a:pPr>
-                    <a:defRPr sz="1200" b="0" i="0" u="none" strike="noStrike">
-                      <a:solidFill>
-                        <a:srgbClr val="FFFFFF"/>
-                      </a:solidFill>
-                      <a:latin typeface="+mn-lt"/>
-                    </a:defRPr>
-                  </a:pPr>
-                </a:p>
-              </c:txPr>
-              <c:showLegendKey val="0"/>
-              <c:showVal val="0"/>
-              <c:showCatName val="0"/>
-              <c:showSerName val="0"/>
-              <c:showPercent val="1"/>
-              <c:showBubbleSize val="0"/>
-            </c:dLbl>
-            <c:dLbl>
-              <c:idx val="1"/>
-              <c:numFmt formatCode="0%" sourceLinked="0"/>
-              <c:spPr/>
-              <c:txPr>
-                <a:bodyPr/>
-                <a:lstStyle/>
-                <a:p>
-                  <a:pPr>
-                    <a:defRPr sz="1200" b="0" i="0" u="none" strike="noStrike">
-                      <a:solidFill>
-                        <a:srgbClr val="FFFFFF"/>
-                      </a:solidFill>
-                      <a:latin typeface="+mn-lt"/>
-                    </a:defRPr>
-                  </a:pPr>
-                </a:p>
-              </c:txPr>
-              <c:showLegendKey val="0"/>
-              <c:showVal val="0"/>
-              <c:showCatName val="0"/>
-              <c:showSerName val="0"/>
-              <c:showPercent val="1"/>
-              <c:showBubbleSize val="0"/>
-            </c:dLbl>
-            <c:dLbl>
-              <c:idx val="2"/>
-              <c:numFmt formatCode="0%" sourceLinked="0"/>
-              <c:spPr/>
-              <c:txPr>
-                <a:bodyPr/>
-                <a:lstStyle/>
-                <a:p>
-                  <a:pPr>
-                    <a:defRPr sz="1200" b="0" i="0" u="none" strike="noStrike">
-                      <a:solidFill>
-                        <a:srgbClr val="FFFFFF"/>
-                      </a:solidFill>
-                      <a:latin typeface="+mn-lt"/>
-                    </a:defRPr>
-                  </a:pPr>
-                </a:p>
-              </c:txPr>
-              <c:showLegendKey val="0"/>
-              <c:showVal val="0"/>
-              <c:showCatName val="0"/>
-              <c:showSerName val="0"/>
-              <c:showPercent val="1"/>
-              <c:showBubbleSize val="0"/>
-            </c:dLbl>
-            <c:numFmt formatCode="0%" sourceLinked="0"/>
+            <c:numFmt formatCode="0.##;;;" sourceLinked="0"/>
             <c:txPr>
               <a:bodyPr/>
               <a:lstStyle/>
               <a:p>
                 <a:pPr>
-                  <a:defRPr sz="1800" b="0" i="0" u="none" strike="noStrike">
+                  <a:defRPr b="0" i="0" strike="noStrike" sz="1100" u="none">
                     <a:solidFill>
-                      <a:srgbClr val="000000"/>
+                      <a:srgbClr val="FFFFFF"/>
                     </a:solidFill>
-                    <a:latin typeface="Arial"/>
+                    <a:latin typeface="+mn-lt"/>
                   </a:defRPr>
                 </a:pPr>
               </a:p>
             </c:txPr>
+            <c:dLblPos val="ctr"/>
             <c:showLegendKey val="0"/>
-            <c:showVal val="0"/>
-            <c:showCatName val="1"/>
+            <c:showVal val="1"/>
+            <c:showCatName val="0"/>
             <c:showSerName val="0"/>
-            <c:showPercent val="1"/>
+            <c:showPercent val="0"/>
             <c:showBubbleSize val="0"/>
             <c:showLeaderLines val="0"/>
           </c:dLbls>
           <c:cat>
-            <c:strRef>
-              <c:f>Sheet1!$A$2:$A$4</c:f>
-              <c:strCache>
-                <c:ptCount val="3"/>
-                <c:pt idx="0">
-                  <c:v>Pauta digital (awareness + leads)</c:v>
-                </c:pt>
-                <c:pt idx="1">
-                  <c:v>SEO + GEO</c:v>
-                </c:pt>
-                <c:pt idx="2">
-                  <c:v>Herramientas y medición</c:v>
-                </c:pt>
-              </c:strCache>
-            </c:strRef>
+            <c:multiLvlStrRef>
+              <c:f>Sheet1!$A$2:$A$3</c:f>
+              <c:multiLvlStrCache>
+                <c:ptCount val="2"/>
+                <c:lvl>
+                  <c:pt idx="0">
+                    <c:v>2026 ejecutado</c:v>
+                  </c:pt>
+                  <c:pt idx="1">
+                    <c:v>2027 solicitado</c:v>
+                  </c:pt>
+                </c:lvl>
+              </c:multiLvlStrCache>
+            </c:multiLvlStrRef>
           </c:cat>
           <c:val>
             <c:numRef>
-              <c:f>Sheet1!$B$2:$B$4</c:f>
+              <c:f>Sheet1!$B$2:$B$3</c:f>
               <c:numCache>
-                <c:ptCount val="3"/>
+                <c:formatCode>General</c:formatCode>
+                <c:ptCount val="2"/>
                 <c:pt idx="0">
-                  <c:v>24</c:v>
+                  <c:v>15</c:v>
                 </c:pt>
                 <c:pt idx="1">
-                  <c:v>22</c:v>
-                </c:pt>
-                <c:pt idx="2">
-                  <c:v>6</c:v>
+                  <c:v>24</c:v>
                 </c:pt>
               </c:numCache>
             </c:numRef>
           </c:val>
         </c:ser>
-        <c:firstSliceAng val="0"/>
-        <c:holeSize val="58"/>
-      </c:doughnutChart>
+        <c:ser>
+          <c:idx val="1"/>
+          <c:order val="1"/>
+          <c:tx>
+            <c:strRef>
+              <c:f>Sheet1!$C$1</c:f>
+              <c:strCache>
+                <c:ptCount val="1"/>
+                <c:pt idx="0">
+                  <c:v>Agencia SEO, GEO y web (COP 45M ≈ US$11,25K)</c:v>
+                </c:pt>
+              </c:strCache>
+            </c:strRef>
+          </c:tx>
+          <c:spPr>
+            <a:solidFill>
+              <a:srgbClr val="1B3A52"/>
+            </a:solidFill>
+            <a:effectLst/>
+          </c:spPr>
+          <c:invertIfNegative val="0"/>
+          <c:dLbls>
+            <c:numFmt formatCode="0.##;;;" sourceLinked="0"/>
+            <c:txPr>
+              <a:bodyPr/>
+              <a:lstStyle/>
+              <a:p>
+                <a:pPr>
+                  <a:defRPr b="0" i="0" strike="noStrike" sz="1100" u="none">
+                    <a:solidFill>
+                      <a:srgbClr val="FFFFFF"/>
+                    </a:solidFill>
+                    <a:latin typeface="+mn-lt"/>
+                  </a:defRPr>
+                </a:pPr>
+              </a:p>
+            </c:txPr>
+            <c:dLblPos val="ctr"/>
+            <c:showLegendKey val="0"/>
+            <c:showVal val="1"/>
+            <c:showCatName val="0"/>
+            <c:showSerName val="0"/>
+            <c:showPercent val="0"/>
+            <c:showBubbleSize val="0"/>
+            <c:showLeaderLines val="0"/>
+          </c:dLbls>
+          <c:cat>
+            <c:multiLvlStrRef>
+              <c:f>Sheet1!$A$2:$A$3</c:f>
+              <c:multiLvlStrCache>
+                <c:ptCount val="2"/>
+                <c:lvl>
+                  <c:pt idx="0">
+                    <c:v>2026 ejecutado</c:v>
+                  </c:pt>
+                  <c:pt idx="1">
+                    <c:v>2027 solicitado</c:v>
+                  </c:pt>
+                </c:lvl>
+              </c:multiLvlStrCache>
+            </c:multiLvlStrRef>
+          </c:cat>
+          <c:val>
+            <c:numRef>
+              <c:f>Sheet1!$C$2:$C$3</c:f>
+              <c:numCache>
+                <c:formatCode>General</c:formatCode>
+                <c:ptCount val="2"/>
+                <c:pt idx="0">
+                  <c:v>0</c:v>
+                </c:pt>
+                <c:pt idx="1">
+                  <c:v>11.25</c:v>
+                </c:pt>
+              </c:numCache>
+            </c:numRef>
+          </c:val>
+        </c:ser>
+        <c:dLbls>
+          <c:numFmt formatCode="0.##;;;" sourceLinked="0"/>
+          <c:txPr>
+            <a:bodyPr/>
+            <a:lstStyle/>
+            <a:p>
+              <a:pPr>
+                <a:defRPr b="0" i="0" strike="noStrike" sz="1100" u="none">
+                  <a:solidFill>
+                    <a:srgbClr val="FFFFFF"/>
+                  </a:solidFill>
+                  <a:latin typeface="+mn-lt"/>
+                </a:defRPr>
+              </a:pPr>
+            </a:p>
+          </c:txPr>
+          <c:dLblPos val="ctr"/>
+          <c:showLegendKey val="0"/>
+          <c:showVal val="1"/>
+          <c:showCatName val="0"/>
+          <c:showSerName val="0"/>
+          <c:showPercent val="0"/>
+          <c:showBubbleSize val="0"/>
+          <c:showLeaderLines val="0"/>
+        </c:dLbls>
+        <c:gapWidth val="55"/>
+        <c:overlap val="100"/>
+        <c:axId val="2094734554"/>
+        <c:axId val="2094734552"/>
+        <c:axId val="2094734556"/>
+      </c:barChart>
+      <c:catAx>
+        <c:axId val="2094734554"/>
+        <c:scaling>
+          <c:orientation val="minMax"/>
+        </c:scaling>
+        <c:delete val="0"/>
+        <c:axPos val="b"/>
+        <c:numFmt formatCode="General" sourceLinked="1"/>
+        <c:majorTickMark val="out"/>
+        <c:minorTickMark val="none"/>
+        <c:tickLblPos val="low"/>
+        <c:spPr>
+          <a:ln w="12700" cap="flat">
+            <a:solidFill>
+              <a:srgbClr val="888888"/>
+            </a:solidFill>
+            <a:prstDash val="solid"/>
+            <a:round/>
+          </a:ln>
+        </c:spPr>
+        <c:txPr>
+          <a:bodyPr/>
+          <a:lstStyle/>
+          <a:p>
+            <a:pPr>
+              <a:defRPr sz="1100" b="0" i="0" u="none" strike="noStrike">
+                <a:solidFill>
+                  <a:srgbClr val="5A6873"/>
+                </a:solidFill>
+                <a:latin typeface="+mn-lt"/>
+              </a:defRPr>
+            </a:pPr>
+            <a:endParaRPr lang="en-US"/>
+          </a:p>
+        </c:txPr>
+        <c:crossAx val="2094734552"/>
+        <c:crosses val="autoZero"/>
+        <c:auto val="1"/>
+        <c:lblAlgn val="ctr"/>
+        <c:noMultiLvlLbl val="1"/>
+      </c:catAx>
+      <c:valAx>
+        <c:axId val="2094734552"/>
+        <c:scaling>
+          <c:orientation val="minMax"/>
+        </c:scaling>
+        <c:delete val="1"/>
+        <c:axPos val="l"/>
+        <c:numFmt formatCode="General" sourceLinked="0"/>
+        <c:majorTickMark val="out"/>
+        <c:minorTickMark val="none"/>
+        <c:tickLblPos val="nextTo"/>
+        <c:spPr>
+          <a:ln w="12700" cap="flat">
+            <a:solidFill>
+              <a:srgbClr val="888888"/>
+            </a:solidFill>
+            <a:prstDash val="solid"/>
+            <a:round/>
+          </a:ln>
+        </c:spPr>
+        <c:txPr>
+          <a:bodyPr/>
+          <a:lstStyle/>
+          <a:p>
+            <a:pPr>
+              <a:defRPr sz="1200" b="0" i="0" u="none" strike="noStrike">
+                <a:solidFill>
+                  <a:srgbClr val="000000"/>
+                </a:solidFill>
+                <a:latin typeface="Arial"/>
+              </a:defRPr>
+            </a:pPr>
+            <a:endParaRPr lang="en-US"/>
+          </a:p>
+        </c:txPr>
+        <c:crossAx val="2094734554"/>
+        <c:crosses val="autoZero"/>
+        <c:crossBetween val="between"/>
+      </c:valAx>
       <c:spPr>
         <a:noFill/>
         <a:ln>
@@ -768,7 +872,7 @@
                 </a:solidFill>
                 <a:latin typeface="+mn-lt"/>
               </a:rPr>
-              <a:t>Revenue de clientes nuevos (US$ miles)</a:t>
+              <a:t>Clientes nuevos: 2026 vs. punto de equilibrio 2027</a:t>
             </a:r>
           </a:p>
         </c:rich>
@@ -781,7 +885,7 @@
       <c:layout/>
       <c:barChart>
         <c:barDir val="col"/>
-        <c:grouping val="stacked"/>
+        <c:grouping val="clustered"/>
         <c:varyColors val="0"/>
         <c:ser>
           <c:idx val="0"/>
@@ -792,20 +896,20 @@
               <c:strCache>
                 <c:ptCount val="1"/>
                 <c:pt idx="0">
-                  <c:v>Pauta</c:v>
+                  <c:v>2026 real</c:v>
                 </c:pt>
               </c:strCache>
             </c:strRef>
           </c:tx>
           <c:spPr>
             <a:solidFill>
-              <a:srgbClr val="D9701A"/>
+              <a:srgbClr val="9FB3C4"/>
             </a:solidFill>
             <a:effectLst/>
           </c:spPr>
           <c:invertIfNegative val="0"/>
           <c:dLbls>
-            <c:numFmt formatCode="0;;;" sourceLinked="0"/>
+            <c:numFmt formatCode="#,##0" sourceLinked="0"/>
             <c:txPr>
               <a:bodyPr/>
               <a:lstStyle/>
@@ -813,14 +917,13 @@
                 <a:pPr>
                   <a:defRPr b="0" i="0" strike="noStrike" sz="1100" u="none">
                     <a:solidFill>
-                      <a:srgbClr val="FFFFFF"/>
+                      <a:srgbClr val="13202A"/>
                     </a:solidFill>
                     <a:latin typeface="+mn-lt"/>
                   </a:defRPr>
                 </a:pPr>
               </a:p>
             </c:txPr>
-            <c:dLblPos val="ctr"/>
             <c:showLegendKey val="0"/>
             <c:showVal val="1"/>
             <c:showCatName val="0"/>
@@ -836,10 +939,10 @@
                 <c:ptCount val="2"/>
                 <c:lvl>
                   <c:pt idx="0">
-                    <c:v>2026 real</c:v>
+                    <c:v>Clientes por pauta</c:v>
                   </c:pt>
                   <c:pt idx="1">
-                    <c:v>2027 meta</c:v>
+                    <c:v>Clientes orgánico + directo</c:v>
                   </c:pt>
                 </c:lvl>
               </c:multiLvlStrCache>
@@ -852,10 +955,10 @@
                 <c:formatCode>General</c:formatCode>
                 <c:ptCount val="2"/>
                 <c:pt idx="0">
-                  <c:v>14.3</c:v>
+                  <c:v>1</c:v>
                 </c:pt>
                 <c:pt idx="1">
-                  <c:v>25</c:v>
+                  <c:v>18</c:v>
                 </c:pt>
               </c:numCache>
             </c:numRef>
@@ -870,20 +973,20 @@
               <c:strCache>
                 <c:ptCount val="1"/>
                 <c:pt idx="0">
-                  <c:v>Orgánico + directo (base)</c:v>
+                  <c:v>2027 mínimo para cubrir la inversión</c:v>
                 </c:pt>
               </c:strCache>
             </c:strRef>
           </c:tx>
           <c:spPr>
             <a:solidFill>
-              <a:srgbClr val="1B3A52"/>
+              <a:srgbClr val="D9701A"/>
             </a:solidFill>
             <a:effectLst/>
           </c:spPr>
           <c:invertIfNegative val="0"/>
           <c:dLbls>
-            <c:numFmt formatCode="0;;;" sourceLinked="0"/>
+            <c:numFmt formatCode="#,##0" sourceLinked="0"/>
             <c:txPr>
               <a:bodyPr/>
               <a:lstStyle/>
@@ -891,14 +994,13 @@
                 <a:pPr>
                   <a:defRPr b="0" i="0" strike="noStrike" sz="1100" u="none">
                     <a:solidFill>
-                      <a:srgbClr val="FFFFFF"/>
+                      <a:srgbClr val="13202A"/>
                     </a:solidFill>
                     <a:latin typeface="+mn-lt"/>
                   </a:defRPr>
                 </a:pPr>
               </a:p>
             </c:txPr>
-            <c:dLblPos val="ctr"/>
             <c:showLegendKey val="0"/>
             <c:showVal val="1"/>
             <c:showCatName val="0"/>
@@ -914,10 +1016,10 @@
                 <c:ptCount val="2"/>
                 <c:lvl>
                   <c:pt idx="0">
-                    <c:v>2026 real</c:v>
+                    <c:v>Clientes por pauta</c:v>
                   </c:pt>
                   <c:pt idx="1">
-                    <c:v>2027 meta</c:v>
+                    <c:v>Clientes orgánico + directo</c:v>
                   </c:pt>
                 </c:lvl>
               </c:multiLvlStrCache>
@@ -930,95 +1032,17 @@
                 <c:formatCode>General</c:formatCode>
                 <c:ptCount val="2"/>
                 <c:pt idx="0">
-                  <c:v>83</c:v>
+                  <c:v>5</c:v>
                 </c:pt>
                 <c:pt idx="1">
-                  <c:v>83</c:v>
-                </c:pt>
-              </c:numCache>
-            </c:numRef>
-          </c:val>
-        </c:ser>
-        <c:ser>
-          <c:idx val="2"/>
-          <c:order val="2"/>
-          <c:tx>
-            <c:strRef>
-              <c:f>Sheet1!$D$1</c:f>
-              <c:strCache>
-                <c:ptCount val="1"/>
-                <c:pt idx="0">
-                  <c:v>SEO + GEO (nuevo)</c:v>
-                </c:pt>
-              </c:strCache>
-            </c:strRef>
-          </c:tx>
-          <c:spPr>
-            <a:solidFill>
-              <a:srgbClr val="1F7A4D"/>
-            </a:solidFill>
-            <a:effectLst/>
-          </c:spPr>
-          <c:invertIfNegative val="0"/>
-          <c:dLbls>
-            <c:numFmt formatCode="0;;;" sourceLinked="0"/>
-            <c:txPr>
-              <a:bodyPr/>
-              <a:lstStyle/>
-              <a:p>
-                <a:pPr>
-                  <a:defRPr b="0" i="0" strike="noStrike" sz="1100" u="none">
-                    <a:solidFill>
-                      <a:srgbClr val="FFFFFF"/>
-                    </a:solidFill>
-                    <a:latin typeface="+mn-lt"/>
-                  </a:defRPr>
-                </a:pPr>
-              </a:p>
-            </c:txPr>
-            <c:dLblPos val="ctr"/>
-            <c:showLegendKey val="0"/>
-            <c:showVal val="1"/>
-            <c:showCatName val="0"/>
-            <c:showSerName val="0"/>
-            <c:showPercent val="0"/>
-            <c:showBubbleSize val="0"/>
-            <c:showLeaderLines val="0"/>
-          </c:dLbls>
-          <c:cat>
-            <c:multiLvlStrRef>
-              <c:f>Sheet1!$A$2:$A$3</c:f>
-              <c:multiLvlStrCache>
-                <c:ptCount val="2"/>
-                <c:lvl>
-                  <c:pt idx="0">
-                    <c:v>2026 real</c:v>
-                  </c:pt>
-                  <c:pt idx="1">
-                    <c:v>2027 meta</c:v>
-                  </c:pt>
-                </c:lvl>
-              </c:multiLvlStrCache>
-            </c:multiLvlStrRef>
-          </c:cat>
-          <c:val>
-            <c:numRef>
-              <c:f>Sheet1!$D$2:$D$3</c:f>
-              <c:numCache>
-                <c:formatCode>General</c:formatCode>
-                <c:ptCount val="2"/>
-                <c:pt idx="0">
-                  <c:v>0</c:v>
-                </c:pt>
-                <c:pt idx="1">
-                  <c:v>28</c:v>
+                  <c:v>21</c:v>
                 </c:pt>
               </c:numCache>
             </c:numRef>
           </c:val>
         </c:ser>
         <c:dLbls>
-          <c:numFmt formatCode="0;;;" sourceLinked="0"/>
+          <c:numFmt formatCode="#,##0" sourceLinked="0"/>
           <c:txPr>
             <a:bodyPr/>
             <a:lstStyle/>
@@ -1026,14 +1050,13 @@
               <a:pPr>
                 <a:defRPr b="0" i="0" strike="noStrike" sz="1100" u="none">
                   <a:solidFill>
-                    <a:srgbClr val="FFFFFF"/>
+                    <a:srgbClr val="13202A"/>
                   </a:solidFill>
                   <a:latin typeface="+mn-lt"/>
                 </a:defRPr>
               </a:pPr>
             </a:p>
           </c:txPr>
-          <c:dLblPos val="ctr"/>
           <c:showLegendKey val="0"/>
           <c:showVal val="1"/>
           <c:showCatName val="0"/>
@@ -1043,7 +1066,7 @@
           <c:showLeaderLines val="0"/>
         </c:dLbls>
         <c:gapWidth val="55"/>
-        <c:overlap val="100"/>
+        <c:overlap val="0"/>
         <c:axId val="2094734554"/>
         <c:axId val="2094734552"/>
         <c:axId val="2094734556"/>
@@ -1567,7 +1590,7 @@
           <a:p>
             <a:r>
               <a:rPr lang="en-US" dirty="0"/>
-              <a:t>Mensaje: en 2026 invertimos US$15.000 en pauta (Google Search y Meta): 70 leads, 18 calificados, 1 venta de US$14.330. CPL US$214, costo por lead calificado US$833, CAC US$15.000, ROAS 0,96x sobre revenue (no sobre margen). Orgánico + directo trajo 186 leads, 90 calificados y 18 clientes por US$83.000: 95% de los clientes y 85% del revenue. Calidad: 48% de los leads orgánicos califican (pauta 26%) y 20% de los calificados cierran (pauta 5,6%). Matiz importante: 'orgánico + directo' incluye a quien ya nos conoce (marca, referidos); 8 de cada 10 visitas orgánicas buscan 'GLT' por nombre. El motor funciona, pero solo con demanda que ya existe. Con 1 sola venta por pauta, la muestra es pequeña; no concluimos que la pauta no sirve, sino que como la hicimos no se paga.</a:t>
+              <a:t>Datos 2026 (internos): pauta US$15.000 en Google Search y Meta → 70 leads, 18 calificados, 1 venta de US$14.330. Costo por lead US$214, por lead calificado US$833, por cliente US$15.000; revenue/inversión 0,96x. Orgánico + directo → 186 leads, 90 calificados, 18 clientes, US$83.000. Calidad: 48% de los leads orgánicos califica (pauta 26%) y 20% de los calificados cierra (pauta 5,6%). Matiz: 'orgánico + directo' incluye a quien ya nos conoce; según OpenRush (28 oct 2026), 8 de cada 10 visitas orgánicas buscan 'GLT' por nombre. Con 1 sola venta por pauta la muestra es chica: la conclusión no es que la pauta no sirva, sino que como la hicimos no se pagó.</a:t>
             </a:r>
             <a:endParaRPr lang="en-US" dirty="0"/>
           </a:p>
@@ -1655,7 +1678,7 @@
           <a:p>
             <a:r>
               <a:rPr lang="en-US" dirty="0"/>
-              <a:t>Mensaje: el presupuesto crece de forma proporcional a la evidencia. Pauta: US$24K (60% más que 2026) pero rediseñada. Salimos de Meta como canal de captación en frío (queda solo para remarketing, agentes y carriers), concentramos Google en búsquedas de nicho y en español en México (clic de ~US$3 frente a US$16–30 en EE. UU.), y probamos LinkedIn a cuentas objetivo con US$4,8K. SEO + GEO: US$22K para que el canal que ya trae el 95% de los clientes encuentre demanda nueva, no solo la de quien ya nos conoce. Herramientas: US$6K. Reglas: liberación trimestral, meta de costo por cliente ≤US$5K, y si al cierre del Q2 supera US$8K, el saldo se mueve a SEO + GEO. Pendiente con Finanzas: margen bruto y retención por cliente para calcular el valor de vida.</a:t>
+              <a:t>Lo que pedimos: US$24.000 de pauta digital de marca GLT (leads y awareness) y COP 45 millones para la agencia digital de SEO, GEO y optimización del sitio. Conversión de referencia: COP 45M ≈ US$11.250 a la TRM de $4.000 usada en la matriz de evaluación de agencias; Finanzas debe ajustarla a la TRM vigente. Total ≈ US$35.250 frente a US$15.000 de pauta en 2026. La pauta sube 60%, pero cambia de enfoque: la de 2026 no se pagó. Por eso Meta sale de la captación en frío, Google se concentra en búsquedas de nicho y en español en México, y hay regla de pausa en el Q2. La agencia invierte en el canal que ya trae el 95% de los clientes, para que también traiga a quien todavía no nos conoce. Por confirmar: si la gestión de la pauta la hace el equipo interno o la agencia, porque las propuestas de agencia cobran esa gestión aparte del adspend.</a:t>
             </a:r>
             <a:endParaRPr lang="en-US" dirty="0"/>
           </a:p>
@@ -1743,7 +1766,7 @@
           <a:p>
             <a:r>
               <a:rPr lang="en-US" dirty="0"/>
-              <a:t>Mensaje: con US$52K buscamos pasar de US$97K a US$130–150K de revenue de clientes nuevos traídos por marketing, y de 19 a ~30 clientes. Supuestos (escenario, no pronóstico): pauta con CPL ~US$200, 35% de leads calificados y 12% de cierre = ~5 clientes y ~US$25K; orgánico + directo se mantiene en US$83K; SEO + GEO suma ~75 leads nuevos sin marca, ~6 clientes y ~US$23–37K, asumiendo que convierten la mitad de bien que los leads de marca. El retorno del primer año sobre el incremento de inversión es cercano a 1x; el caso se completa con la recompra de los clientes (valor de vida), que Finanzas debe confirmar. Si al cierre del Q2 la pauta no cumple, movemos el saldo al motor orgánico.</a:t>
+              <a:t>Punto de equilibrio con datos de 2026 (sobre revenue, no sobre margen). Pauta: US$24.000 ÷ US$5.123 de revenue promedio por cliente (US$97.330 ÷ 19) ≈ 4,7 → 5 clientes; en 2026 fue 1. Para lograrlo con un volumen de leads similar hay que mejorar la calidad: más leads calificados y más cierre, por eso cambia la segmentación. Agencia: ≈US$11.250 ÷ US$4.611 de revenue promedio por cliente orgánico (US$83.000 ÷ 18) ≈ 2,4 → 3 clientes más, de 18 a 21; al 9,7% de conversión de lead a cliente orgánico de 2026, son unos 31 leads orgánicos más. El revenue no es margen: Finanzas debe validar margen bruto y recompra. Las metas son propuestas de seguimiento, no promesas.</a:t>
             </a:r>
             <a:endParaRPr lang="en-US" dirty="0"/>
           </a:p>
@@ -2497,7 +2520,7 @@
                 <a:ea typeface="Cambria" pitchFamily="34" charset="-122"/>
                 <a:cs typeface="Cambria" pitchFamily="34" charset="-120"/>
               </a:rPr>
-              <a:t>95%</a:t>
+              <a:t>95% · 85%</a:t>
             </a:r>
             <a:endParaRPr lang="en-US" sz="2600" dirty="0"/>
           </a:p>
@@ -2528,14 +2551,14 @@
               <a:buNone/>
             </a:pPr>
             <a:r>
-              <a:rPr lang="en-US" sz="1200" dirty="0">
+              <a:rPr lang="en-US" sz="1150" dirty="0">
                 <a:solidFill>
                   <a:schemeClr val="tx1"/>
                 </a:solidFill>
               </a:rPr>
-              <a:t>de los clientes nuevos (18 de 19) y 85% del revenue vinieron de orgánico + directo</a:t>
+              <a:t>de los clientes nuevos (18 de 19) y del revenue (US$83K de US$97K) vinieron de orgánico + directo</a:t>
             </a:r>
-            <a:endParaRPr lang="en-US" sz="1200" dirty="0"/>
+            <a:endParaRPr lang="en-US" sz="1150" dirty="0"/>
           </a:p>
         </p:txBody>
       </p:sp>
@@ -2628,14 +2651,14 @@
               <a:buNone/>
             </a:pPr>
             <a:r>
-              <a:rPr lang="en-US" sz="1200" dirty="0">
+              <a:rPr lang="en-US" sz="1150" dirty="0">
                 <a:solidFill>
                   <a:schemeClr val="tx1"/>
                 </a:solidFill>
               </a:rPr>
-              <a:t>costó cada cliente por pauta en 2026 (1 venta; ROAS 0,96x en revenue)</a:t>
+              <a:t>costó el único cliente que trajo la pauta (US$14.330 de revenue; 0,96x lo invertido)</a:t>
             </a:r>
-            <a:endParaRPr lang="en-US" sz="1200" dirty="0"/>
+            <a:endParaRPr lang="en-US" sz="1150" dirty="0"/>
           </a:p>
         </p:txBody>
       </p:sp>
@@ -2728,14 +2751,14 @@
               <a:buNone/>
             </a:pPr>
             <a:r>
-              <a:rPr lang="en-US" sz="1200" dirty="0">
+              <a:rPr lang="en-US" sz="1150" dirty="0">
                 <a:solidFill>
                   <a:schemeClr val="tx1"/>
                 </a:solidFill>
               </a:rPr>
-              <a:t>de los leads calificados se vuelven clientes: orgánico vs. pauta</a:t>
+              <a:t>de los leads calificados se volvieron clientes: orgánico vs. pauta</a:t>
             </a:r>
-            <a:endParaRPr lang="en-US" sz="1200" dirty="0"/>
+            <a:endParaRPr lang="en-US" sz="1150" dirty="0"/>
           </a:p>
         </p:txBody>
       </p:sp>
@@ -2844,7 +2867,7 @@
                 <a:ea typeface="Cambria" pitchFamily="34" charset="-122"/>
                 <a:cs typeface="Cambria" pitchFamily="34" charset="-120"/>
               </a:rPr>
-              <a:t>2027: US$52K con la pauta rediseñada</a:t>
+              <a:t>2027: US$24K en pauta y COP 45M en agencia</a:t>
             </a:r>
             <a:endParaRPr lang="en-US" sz="2600" dirty="0"/>
           </a:p>
@@ -2852,13 +2875,13 @@
       </p:sp>
       <p:graphicFrame>
         <p:nvGraphicFramePr>
-          <p:cNvPr id="3" name="chart-budget-split" descr=""/>
+          <p:cNvPr id="3" name="chart-spend" descr=""/>
           <p:cNvGraphicFramePr/>
           <p:nvPr/>
         </p:nvGraphicFramePr>
         <p:xfrm>
           <a:off x="365760" y="1005840"/>
-          <a:ext cx="3383280" cy="2743200"/>
+          <a:ext cx="3931920" cy="3611880"/>
         </p:xfrm>
         <a:graphic xmlns:a="http://schemas.openxmlformats.org/drawingml/2006/main">
           <a:graphicData uri="http://schemas.openxmlformats.org/drawingml/2006/chart">
@@ -2868,461 +2891,14 @@
       </p:graphicFrame>
       <p:sp>
         <p:nvSpPr>
-          <p:cNvPr id="4" name="donut-center"/>
-          <p:cNvSpPr txBox="1"/>
+          <p:cNvPr id="4" name="card-paid"/>
+          <p:cNvSpPr/>
           <p:nvPr/>
         </p:nvSpPr>
         <p:spPr>
           <a:xfrm>
-            <a:off x="1143000" y="1783080"/>
-            <a:ext cx="1828800" cy="685800"/>
-          </a:xfrm>
-          <a:prstGeom prst="rect">
-            <a:avLst/>
-          </a:prstGeom>
-          <a:noFill/>
-          <a:ln/>
-        </p:spPr>
-        <p:txBody>
-          <a:bodyPr wrap="square" lIns="0" tIns="0" rIns="0" bIns="0" rtlCol="0" anchor="ctr"/>
-          <a:lstStyle/>
-          <a:p>
-            <a:pPr algn="ctr" indent="0" marL="0">
-              <a:buNone/>
-            </a:pPr>
-            <a:r>
-              <a:rPr lang="en-US" sz="2000" b="1" dirty="0">
-                <a:solidFill>
-                  <a:schemeClr val="tx2"/>
-                </a:solidFill>
-              </a:rPr>
-              <a:t>US$52K</a:t>
-            </a:r>
-            <a:endParaRPr lang="en-US" sz="2000" dirty="0"/>
-          </a:p>
-          <a:p>
-            <a:pPr algn="ctr" indent="0" marL="0">
-              <a:buNone/>
-            </a:pPr>
-            <a:r>
-              <a:rPr lang="en-US" sz="1100" dirty="0">
-                <a:solidFill>
-                  <a:schemeClr val="accent3"/>
-                </a:solidFill>
-              </a:rPr>
-              <a:t>total 2027</a:t>
-            </a:r>
-            <a:endParaRPr lang="en-US" sz="2000" dirty="0"/>
-          </a:p>
-        </p:txBody>
-      </p:sp>
-      <p:graphicFrame>
-        <p:nvGraphicFramePr>
-          <p:cNvPr id="3" name="table-budget"/>
-          <p:cNvGraphicFramePr>
-            <a:graphicFrameLocks noGrp="1"/>
-          </p:cNvGraphicFramePr>
-          <p:nvPr>
-            <p:extLst>
-              <p:ext uri="{D42A27DB-BD31-4B8C-83A1-F6EECF244321}">
-                <p14:modId xmlns:p14="http://schemas.microsoft.com/office/powerpoint/2010/main" val="1579011935"/>
-              </p:ext>
-            </p:extLst>
-          </p:nvPr>
-        </p:nvGraphicFramePr>
-        <p:xfrm>
-          <a:off x="4023360" y="1005840"/>
-          <a:ext cx="4663440" cy="914400"/>
-        </p:xfrm>
-        <a:graphic>
-          <a:graphicData uri="http://schemas.openxmlformats.org/drawingml/2006/table">
-            <a:tbl>
-              <a:tblPr/>
-              <a:tblGrid>
-                <a:gridCol w="960120"/>
-                <a:gridCol w="731520"/>
-                <a:gridCol w="2971800"/>
-              </a:tblGrid>
-              <a:tr h="658368">
-                <a:tc>
-                  <a:txBody>
-                    <a:bodyPr/>
-                    <a:lstStyle/>
-                    <a:p>
-                      <a:pPr indent="0" marL="0">
-                        <a:buNone/>
-                      </a:pPr>
-                      <a:r>
-                        <a:rPr lang="en-US" sz="1200" b="1" dirty="0">
-                          <a:solidFill>
-                            <a:srgbClr val="1B3A52"/>
-                          </a:solidFill>
-                        </a:rPr>
-                        <a:t>Pauta</a:t>
-                      </a:r>
-                      <a:endParaRPr lang="en-US" sz="1200" dirty="0"/>
-                    </a:p>
-                  </a:txBody>
-                  <a:tcPr marL="50800" marR="50800" marT="38100" marB="38100" anchor="ctr">
-                    <a:lnL w="0" cap="flat" cmpd="sng" algn="ctr">
-                      <a:noFill/>
-                    </a:lnL>
-                    <a:lnR w="0" cap="flat" cmpd="sng" algn="ctr">
-                      <a:noFill/>
-                    </a:lnR>
-                    <a:lnT w="0" cap="flat" cmpd="sng" algn="ctr">
-                      <a:noFill/>
-                    </a:lnT>
-                    <a:lnB w="9525" cap="flat" cmpd="sng" algn="ctr">
-                      <a:solidFill>
-                        <a:srgbClr val="D6DCE0"/>
-                      </a:solidFill>
-                      <a:prstDash val="solid"/>
-                      <a:round/>
-                      <a:headEnd type="none" w="med" len="med"/>
-                      <a:tailEnd type="none" w="med" len="med"/>
-                    </a:lnB>
-                  </a:tcPr>
-                </a:tc>
-                <a:tc>
-                  <a:txBody>
-                    <a:bodyPr/>
-                    <a:lstStyle/>
-                    <a:p>
-                      <a:pPr indent="0" marL="0">
-                        <a:buNone/>
-                      </a:pPr>
-                      <a:r>
-                        <a:rPr lang="en-US" sz="1200" b="1" dirty="0">
-                          <a:solidFill>
-                            <a:srgbClr val="1B3A52"/>
-                          </a:solidFill>
-                        </a:rPr>
-                        <a:t>US$24K</a:t>
-                      </a:r>
-                      <a:endParaRPr lang="en-US" sz="1200" dirty="0"/>
-                    </a:p>
-                  </a:txBody>
-                  <a:tcPr marL="50800" marR="50800" marT="38100" marB="38100" anchor="ctr">
-                    <a:lnL w="0" cap="flat" cmpd="sng" algn="ctr">
-                      <a:noFill/>
-                    </a:lnL>
-                    <a:lnR w="0" cap="flat" cmpd="sng" algn="ctr">
-                      <a:noFill/>
-                    </a:lnR>
-                    <a:lnT w="0" cap="flat" cmpd="sng" algn="ctr">
-                      <a:noFill/>
-                    </a:lnT>
-                    <a:lnB w="9525" cap="flat" cmpd="sng" algn="ctr">
-                      <a:solidFill>
-                        <a:srgbClr val="D6DCE0"/>
-                      </a:solidFill>
-                      <a:prstDash val="solid"/>
-                      <a:round/>
-                      <a:headEnd type="none" w="med" len="med"/>
-                      <a:tailEnd type="none" w="med" len="med"/>
-                    </a:lnB>
-                  </a:tcPr>
-                </a:tc>
-                <a:tc>
-                  <a:txBody>
-                    <a:bodyPr/>
-                    <a:lstStyle/>
-                    <a:p>
-                      <a:pPr indent="0" marL="0">
-                        <a:buNone/>
-                      </a:pPr>
-                      <a:r>
-                        <a:rPr lang="en-US" sz="1050" dirty="0">
-                          <a:solidFill>
-                            <a:srgbClr val="13202A"/>
-                          </a:solidFill>
-                        </a:rPr>
-                        <a:t>Google de nicho EE. UU. (45%) y México en español (15%), LinkedIn a cuentas objetivo (20%), remarketing (10%), awareness (10%). Meta solo remarketing</a:t>
-                      </a:r>
-                      <a:endParaRPr lang="en-US" sz="1050" dirty="0"/>
-                    </a:p>
-                  </a:txBody>
-                  <a:tcPr marL="50800" marR="50800" marT="38100" marB="38100" anchor="ctr">
-                    <a:lnL w="0" cap="flat" cmpd="sng" algn="ctr">
-                      <a:noFill/>
-                    </a:lnL>
-                    <a:lnR w="0" cap="flat" cmpd="sng" algn="ctr">
-                      <a:noFill/>
-                    </a:lnR>
-                    <a:lnT w="0" cap="flat" cmpd="sng" algn="ctr">
-                      <a:noFill/>
-                    </a:lnT>
-                    <a:lnB w="9525" cap="flat" cmpd="sng" algn="ctr">
-                      <a:solidFill>
-                        <a:srgbClr val="D6DCE0"/>
-                      </a:solidFill>
-                      <a:prstDash val="solid"/>
-                      <a:round/>
-                      <a:headEnd type="none" w="med" len="med"/>
-                      <a:tailEnd type="none" w="med" len="med"/>
-                    </a:lnB>
-                  </a:tcPr>
-                </a:tc>
-              </a:tr>
-              <a:tr h="658368">
-                <a:tc>
-                  <a:txBody>
-                    <a:bodyPr/>
-                    <a:lstStyle/>
-                    <a:p>
-                      <a:pPr indent="0" marL="0">
-                        <a:buNone/>
-                      </a:pPr>
-                      <a:r>
-                        <a:rPr lang="en-US" sz="1200" b="1" dirty="0">
-                          <a:solidFill>
-                            <a:srgbClr val="1B3A52"/>
-                          </a:solidFill>
-                        </a:rPr>
-                        <a:t>SEO + GEO</a:t>
-                      </a:r>
-                      <a:endParaRPr lang="en-US" sz="1200" dirty="0"/>
-                    </a:p>
-                  </a:txBody>
-                  <a:tcPr marL="50800" marR="50800" marT="38100" marB="38100" anchor="ctr">
-                    <a:lnL w="0" cap="flat" cmpd="sng" algn="ctr">
-                      <a:noFill/>
-                    </a:lnL>
-                    <a:lnR w="0" cap="flat" cmpd="sng" algn="ctr">
-                      <a:noFill/>
-                    </a:lnR>
-                    <a:lnT w="0" cap="flat" cmpd="sng" algn="ctr">
-                      <a:noFill/>
-                    </a:lnT>
-                    <a:lnB w="9525" cap="flat" cmpd="sng" algn="ctr">
-                      <a:solidFill>
-                        <a:srgbClr val="D6DCE0"/>
-                      </a:solidFill>
-                      <a:prstDash val="solid"/>
-                      <a:round/>
-                      <a:headEnd type="none" w="med" len="med"/>
-                      <a:tailEnd type="none" w="med" len="med"/>
-                    </a:lnB>
-                  </a:tcPr>
-                </a:tc>
-                <a:tc>
-                  <a:txBody>
-                    <a:bodyPr/>
-                    <a:lstStyle/>
-                    <a:p>
-                      <a:pPr indent="0" marL="0">
-                        <a:buNone/>
-                      </a:pPr>
-                      <a:r>
-                        <a:rPr lang="en-US" sz="1200" b="1" dirty="0">
-                          <a:solidFill>
-                            <a:srgbClr val="1B3A52"/>
-                          </a:solidFill>
-                        </a:rPr>
-                        <a:t>US$22K</a:t>
-                      </a:r>
-                      <a:endParaRPr lang="en-US" sz="1200" dirty="0"/>
-                    </a:p>
-                  </a:txBody>
-                  <a:tcPr marL="50800" marR="50800" marT="38100" marB="38100" anchor="ctr">
-                    <a:lnL w="0" cap="flat" cmpd="sng" algn="ctr">
-                      <a:noFill/>
-                    </a:lnL>
-                    <a:lnR w="0" cap="flat" cmpd="sng" algn="ctr">
-                      <a:noFill/>
-                    </a:lnR>
-                    <a:lnT w="0" cap="flat" cmpd="sng" algn="ctr">
-                      <a:noFill/>
-                    </a:lnT>
-                    <a:lnB w="9525" cap="flat" cmpd="sng" algn="ctr">
-                      <a:solidFill>
-                        <a:srgbClr val="D6DCE0"/>
-                      </a:solidFill>
-                      <a:prstDash val="solid"/>
-                      <a:round/>
-                      <a:headEnd type="none" w="med" len="med"/>
-                      <a:tailEnd type="none" w="med" len="med"/>
-                    </a:lnB>
-                  </a:tcPr>
-                </a:tc>
-                <a:tc>
-                  <a:txBody>
-                    <a:bodyPr/>
-                    <a:lstStyle/>
-                    <a:p>
-                      <a:pPr indent="0" marL="0">
-                        <a:buNone/>
-                      </a:pPr>
-                      <a:r>
-                        <a:rPr lang="en-US" sz="1050" dirty="0">
-                          <a:solidFill>
-                            <a:srgbClr val="13202A"/>
-                          </a:solidFill>
-                        </a:rPr>
-                        <a:t>Arreglos técnicos, landings de forwarders, brokers y Magaya, páginas en español, 6–8 videos de YouTube, directorios y reseñas</a:t>
-                      </a:r>
-                      <a:endParaRPr lang="en-US" sz="1050" dirty="0"/>
-                    </a:p>
-                  </a:txBody>
-                  <a:tcPr marL="50800" marR="50800" marT="38100" marB="38100" anchor="ctr">
-                    <a:lnL w="0" cap="flat" cmpd="sng" algn="ctr">
-                      <a:noFill/>
-                    </a:lnL>
-                    <a:lnR w="0" cap="flat" cmpd="sng" algn="ctr">
-                      <a:noFill/>
-                    </a:lnR>
-                    <a:lnT w="0" cap="flat" cmpd="sng" algn="ctr">
-                      <a:noFill/>
-                    </a:lnT>
-                    <a:lnB w="9525" cap="flat" cmpd="sng" algn="ctr">
-                      <a:solidFill>
-                        <a:srgbClr val="D6DCE0"/>
-                      </a:solidFill>
-                      <a:prstDash val="solid"/>
-                      <a:round/>
-                      <a:headEnd type="none" w="med" len="med"/>
-                      <a:tailEnd type="none" w="med" len="med"/>
-                    </a:lnB>
-                  </a:tcPr>
-                </a:tc>
-              </a:tr>
-              <a:tr h="658368">
-                <a:tc>
-                  <a:txBody>
-                    <a:bodyPr/>
-                    <a:lstStyle/>
-                    <a:p>
-                      <a:pPr indent="0" marL="0">
-                        <a:buNone/>
-                      </a:pPr>
-                      <a:r>
-                        <a:rPr lang="en-US" sz="1200" b="1" dirty="0">
-                          <a:solidFill>
-                            <a:srgbClr val="1B3A52"/>
-                          </a:solidFill>
-                        </a:rPr>
-                        <a:t>Herramientas</a:t>
-                      </a:r>
-                      <a:endParaRPr lang="en-US" sz="1200" dirty="0"/>
-                    </a:p>
-                  </a:txBody>
-                  <a:tcPr marL="50800" marR="50800" marT="38100" marB="38100" anchor="ctr">
-                    <a:lnL w="0" cap="flat" cmpd="sng" algn="ctr">
-                      <a:noFill/>
-                    </a:lnL>
-                    <a:lnR w="0" cap="flat" cmpd="sng" algn="ctr">
-                      <a:noFill/>
-                    </a:lnR>
-                    <a:lnT w="0" cap="flat" cmpd="sng" algn="ctr">
-                      <a:noFill/>
-                    </a:lnT>
-                    <a:lnB w="9525" cap="flat" cmpd="sng" algn="ctr">
-                      <a:solidFill>
-                        <a:srgbClr val="D6DCE0"/>
-                      </a:solidFill>
-                      <a:prstDash val="solid"/>
-                      <a:round/>
-                      <a:headEnd type="none" w="med" len="med"/>
-                      <a:tailEnd type="none" w="med" len="med"/>
-                    </a:lnB>
-                  </a:tcPr>
-                </a:tc>
-                <a:tc>
-                  <a:txBody>
-                    <a:bodyPr/>
-                    <a:lstStyle/>
-                    <a:p>
-                      <a:pPr indent="0" marL="0">
-                        <a:buNone/>
-                      </a:pPr>
-                      <a:r>
-                        <a:rPr lang="en-US" sz="1200" b="1" dirty="0">
-                          <a:solidFill>
-                            <a:srgbClr val="1B3A52"/>
-                          </a:solidFill>
-                        </a:rPr>
-                        <a:t>US$6K</a:t>
-                      </a:r>
-                      <a:endParaRPr lang="en-US" sz="1200" dirty="0"/>
-                    </a:p>
-                  </a:txBody>
-                  <a:tcPr marL="50800" marR="50800" marT="38100" marB="38100" anchor="ctr">
-                    <a:lnL w="0" cap="flat" cmpd="sng" algn="ctr">
-                      <a:noFill/>
-                    </a:lnL>
-                    <a:lnR w="0" cap="flat" cmpd="sng" algn="ctr">
-                      <a:noFill/>
-                    </a:lnR>
-                    <a:lnT w="0" cap="flat" cmpd="sng" algn="ctr">
-                      <a:noFill/>
-                    </a:lnT>
-                    <a:lnB w="9525" cap="flat" cmpd="sng" algn="ctr">
-                      <a:solidFill>
-                        <a:srgbClr val="D6DCE0"/>
-                      </a:solidFill>
-                      <a:prstDash val="solid"/>
-                      <a:round/>
-                      <a:headEnd type="none" w="med" len="med"/>
-                      <a:tailEnd type="none" w="med" len="med"/>
-                    </a:lnB>
-                  </a:tcPr>
-                </a:tc>
-                <a:tc>
-                  <a:txBody>
-                    <a:bodyPr/>
-                    <a:lstStyle/>
-                    <a:p>
-                      <a:pPr indent="0" marL="0">
-                        <a:buNone/>
-                      </a:pPr>
-                      <a:r>
-                        <a:rPr lang="en-US" sz="1050" dirty="0">
-                          <a:solidFill>
-                            <a:srgbClr val="13202A"/>
-                          </a:solidFill>
-                        </a:rPr>
-                        <a:t>Datos SEO y de IA, monitoreo de anuncios de la competencia, medición hasta el primer envío</a:t>
-                      </a:r>
-                      <a:endParaRPr lang="en-US" sz="1050" dirty="0"/>
-                    </a:p>
-                  </a:txBody>
-                  <a:tcPr marL="50800" marR="50800" marT="38100" marB="38100" anchor="ctr">
-                    <a:lnL w="0" cap="flat" cmpd="sng" algn="ctr">
-                      <a:noFill/>
-                    </a:lnL>
-                    <a:lnR w="0" cap="flat" cmpd="sng" algn="ctr">
-                      <a:noFill/>
-                    </a:lnR>
-                    <a:lnT w="0" cap="flat" cmpd="sng" algn="ctr">
-                      <a:noFill/>
-                    </a:lnT>
-                    <a:lnB w="9525" cap="flat" cmpd="sng" algn="ctr">
-                      <a:solidFill>
-                        <a:srgbClr val="D6DCE0"/>
-                      </a:solidFill>
-                      <a:prstDash val="solid"/>
-                      <a:round/>
-                      <a:headEnd type="none" w="med" len="med"/>
-                      <a:tailEnd type="none" w="med" len="med"/>
-                    </a:lnB>
-                  </a:tcPr>
-                </a:tc>
-              </a:tr>
-            </a:tbl>
-          </a:graphicData>
-        </a:graphic>
-      </p:graphicFrame>
-      <p:sp>
-        <p:nvSpPr>
-          <p:cNvPr id="6" name="card-rules"/>
-          <p:cNvSpPr/>
-          <p:nvPr/>
-        </p:nvSpPr>
-        <p:spPr>
-          <a:xfrm>
-            <a:off x="4023360" y="3108960"/>
-            <a:ext cx="4663440" cy="1280160"/>
+            <a:off x="4526280" y="1005840"/>
+            <a:ext cx="4160520" cy="1691640"/>
           </a:xfrm>
           <a:prstGeom prst="rect">
             <a:avLst/>
@@ -3340,14 +2916,14 @@
       </p:sp>
       <p:sp>
         <p:nvSpPr>
-          <p:cNvPr id="7" name="text-rules"/>
+          <p:cNvPr id="5" name="text-paid"/>
           <p:cNvSpPr txBox="1"/>
           <p:nvPr/>
         </p:nvSpPr>
         <p:spPr>
           <a:xfrm>
-            <a:off x="4160520" y="3172968"/>
-            <a:ext cx="4434840" cy="1188720"/>
+            <a:off x="4663440" y="1069848"/>
+            <a:ext cx="3931920" cy="1572768"/>
           </a:xfrm>
           <a:prstGeom prst="rect">
             <a:avLst/>
@@ -3368,10 +2944,10 @@
             <a:r>
               <a:rPr lang="en-US" sz="1300" b="1" dirty="0">
                 <a:solidFill>
-                  <a:schemeClr val="tx2"/>
+                  <a:schemeClr val="accent1"/>
                 </a:solidFill>
               </a:rPr>
-              <a:t>Reglas para que la pauta sí se pague</a:t>
+              <a:t>Pauta: US$24K (US$2K/mes), rediseñada</a:t>
             </a:r>
             <a:endParaRPr lang="en-US" sz="1100" dirty="0"/>
           </a:p>
@@ -3389,7 +2965,7 @@
                   <a:schemeClr val="tx1"/>
                 </a:solidFill>
               </a:rPr>
-              <a:t>Se libera por trimestre: US$5K, 6K, 6,5K y 6,5K.</a:t>
+              <a:t>Google en búsquedas de nicho (forwarders, brokers, Magaya, cruce a México) y en español en México.</a:t>
             </a:r>
             <a:endParaRPr lang="en-US" sz="1100" dirty="0"/>
           </a:p>
@@ -3407,7 +2983,7 @@
                   <a:schemeClr val="tx1"/>
                 </a:solidFill>
               </a:rPr>
-              <a:t>Meta: costo por cliente ≤ US$5K (2026: US$15K) y 12% de calificados que cierran (2026: 5,6%).</a:t>
+              <a:t>Meta sale de la captación en frío; queda para remarketing y awareness.</a:t>
             </a:r>
             <a:endParaRPr lang="en-US" sz="1100" dirty="0"/>
           </a:p>
@@ -3425,7 +3001,125 @@
                   <a:schemeClr val="tx1"/>
                 </a:solidFill>
               </a:rPr>
-              <a:t>Si al cierre del Q2 el costo por cliente supera US$8K, el saldo pasa a SEO + GEO.</a:t>
+              <a:t>Se libera por trimestre y se pausa si al cierre del Q2 el costo por cliente supera US$8K.</a:t>
+            </a:r>
+            <a:endParaRPr lang="en-US" sz="1100" dirty="0"/>
+          </a:p>
+        </p:txBody>
+      </p:sp>
+      <p:sp>
+        <p:nvSpPr>
+          <p:cNvPr id="6" name="card-agency"/>
+          <p:cNvSpPr/>
+          <p:nvPr/>
+        </p:nvSpPr>
+        <p:spPr>
+          <a:xfrm>
+            <a:off x="4526280" y="2834640"/>
+            <a:ext cx="4160520" cy="1783080"/>
+          </a:xfrm>
+          <a:prstGeom prst="rect">
+            <a:avLst/>
+          </a:prstGeom>
+          <a:solidFill>
+            <a:schemeClr val="bg2"/>
+          </a:solidFill>
+          <a:ln w="12700">
+            <a:solidFill>
+              <a:schemeClr val="bg2"/>
+            </a:solidFill>
+            <a:prstDash val="solid"/>
+          </a:ln>
+        </p:spPr>
+      </p:sp>
+      <p:sp>
+        <p:nvSpPr>
+          <p:cNvPr id="7" name="text-agency"/>
+          <p:cNvSpPr txBox="1"/>
+          <p:nvPr/>
+        </p:nvSpPr>
+        <p:spPr>
+          <a:xfrm>
+            <a:off x="4663440" y="2898648"/>
+            <a:ext cx="3931920" cy="1664208"/>
+          </a:xfrm>
+          <a:prstGeom prst="rect">
+            <a:avLst/>
+          </a:prstGeom>
+          <a:noFill/>
+          <a:ln/>
+        </p:spPr>
+        <p:txBody>
+          <a:bodyPr wrap="square" lIns="0" tIns="0" rIns="0" bIns="0" rtlCol="0" anchor="t"/>
+          <a:lstStyle/>
+          <a:p>
+            <a:pPr indent="0" marL="0">
+              <a:spcAft>
+                <a:spcPts val="200"/>
+              </a:spcAft>
+              <a:buNone/>
+            </a:pPr>
+            <a:r>
+              <a:rPr lang="en-US" sz="1300" b="1" dirty="0">
+                <a:solidFill>
+                  <a:schemeClr val="tx2"/>
+                </a:solidFill>
+              </a:rPr>
+              <a:t>Agencia: COP 45M (≈ COP 3,75M/mes)</a:t>
+            </a:r>
+            <a:endParaRPr lang="en-US" sz="1100" dirty="0"/>
+          </a:p>
+          <a:p>
+            <a:pPr marL="342900" indent="-342900">
+              <a:spcAft>
+                <a:spcPts val="200"/>
+              </a:spcAft>
+              <a:buSzPct val="100000"/>
+              <a:buChar char="•"/>
+            </a:pPr>
+            <a:r>
+              <a:rPr lang="en-US" sz="1100" dirty="0">
+                <a:solidFill>
+                  <a:schemeClr val="tx1"/>
+                </a:solidFill>
+              </a:rPr>
+              <a:t>SEO: arreglar lo técnico del sitio y crear páginas para lo que la gente busca.</a:t>
+            </a:r>
+            <a:endParaRPr lang="en-US" sz="1100" dirty="0"/>
+          </a:p>
+          <a:p>
+            <a:pPr marL="342900" indent="-342900">
+              <a:spcAft>
+                <a:spcPts val="200"/>
+              </a:spcAft>
+              <a:buSzPct val="100000"/>
+              <a:buChar char="•"/>
+            </a:pPr>
+            <a:r>
+              <a:rPr lang="en-US" sz="1100" dirty="0">
+                <a:solidFill>
+                  <a:schemeClr val="tx1"/>
+                </a:solidFill>
+              </a:rPr>
+              <a:t>GEO: que Google y la IA nos encuentren y nos citen, no solo por nombre.</a:t>
+            </a:r>
+            <a:endParaRPr lang="en-US" sz="1100" dirty="0"/>
+          </a:p>
+          <a:p>
+            <a:pPr marL="342900" indent="-342900">
+              <a:spcAft>
+                <a:spcPts val="200"/>
+              </a:spcAft>
+              <a:buSzPct val="100000"/>
+              <a:buChar char="•"/>
+            </a:pPr>
+            <a:r>
+              <a:rPr lang="en-US" sz="1100" dirty="0">
+                <a:solidFill>
+                  <a:schemeClr val="tx1"/>
+                </a:solidFill>
+              </a:rPr>
+              <a:t>Optimización web: convertir mejor el tráfico que ya trae 95% de los clientes.</a:t>
             </a:r>
             <a:endParaRPr lang="en-US" sz="1100" dirty="0"/>
           </a:p>
@@ -3536,7 +3230,7 @@
                 <a:ea typeface="Cambria" pitchFamily="34" charset="-122"/>
                 <a:cs typeface="Cambria" pitchFamily="34" charset="-120"/>
               </a:rPr>
-              <a:t>Meta 2027: de US$97K a US$130–150K</a:t>
+              <a:t>Para pagarse, cada frente necesita pocos clientes más</a:t>
             </a:r>
             <a:endParaRPr lang="en-US" sz="2600" dirty="0"/>
           </a:p>
@@ -3544,7 +3238,7 @@
       </p:sp>
       <p:graphicFrame>
         <p:nvGraphicFramePr>
-          <p:cNvPr id="3" name="chart-revenue" descr=""/>
+          <p:cNvPr id="3" name="chart-breakeven" descr=""/>
           <p:cNvGraphicFramePr/>
           <p:nvPr/>
         </p:nvGraphicFramePr>
@@ -3560,14 +3254,14 @@
       </p:graphicFrame>
       <p:sp>
         <p:nvSpPr>
-          <p:cNvPr id="4" name="card-gain-lose"/>
+          <p:cNvPr id="4" name="be-card-1"/>
           <p:cNvSpPr/>
           <p:nvPr/>
         </p:nvSpPr>
         <p:spPr>
           <a:xfrm>
             <a:off x="4846320" y="1005840"/>
-            <a:ext cx="3840480" cy="1783080"/>
+            <a:ext cx="3840480" cy="868680"/>
           </a:xfrm>
           <a:prstGeom prst="rect">
             <a:avLst/>
@@ -3585,14 +3279,53 @@
       </p:sp>
       <p:sp>
         <p:nvSpPr>
-          <p:cNvPr id="5" name="text-gain-lose"/>
+          <p:cNvPr id="5" name="be-num-1"/>
           <p:cNvSpPr txBox="1"/>
           <p:nvPr/>
         </p:nvSpPr>
         <p:spPr>
           <a:xfrm>
             <a:off x="4983480" y="1069848"/>
-            <a:ext cx="3611880" cy="1664208"/>
+            <a:ext cx="3566160" cy="365760"/>
+          </a:xfrm>
+          <a:prstGeom prst="rect">
+            <a:avLst/>
+          </a:prstGeom>
+          <a:noFill/>
+          <a:ln/>
+        </p:spPr>
+        <p:txBody>
+          <a:bodyPr wrap="square" lIns="0" tIns="0" rIns="0" bIns="0" rtlCol="0" anchor="ctr"/>
+          <a:lstStyle/>
+          <a:p>
+            <a:pPr indent="0" marL="0">
+              <a:buNone/>
+            </a:pPr>
+            <a:r>
+              <a:rPr lang="en-US" sz="2000" b="1" dirty="0">
+                <a:solidFill>
+                  <a:schemeClr val="accent1"/>
+                </a:solidFill>
+                <a:latin typeface="Cambria" pitchFamily="34" charset="0"/>
+                <a:ea typeface="Cambria" pitchFamily="34" charset="-122"/>
+                <a:cs typeface="Cambria" pitchFamily="34" charset="-120"/>
+              </a:rPr>
+              <a:t>5 clientes</a:t>
+            </a:r>
+            <a:endParaRPr lang="en-US" sz="2000" dirty="0"/>
+          </a:p>
+        </p:txBody>
+      </p:sp>
+      <p:sp>
+        <p:nvSpPr>
+          <p:cNvPr id="6" name="be-label-1"/>
+          <p:cNvSpPr txBox="1"/>
+          <p:nvPr/>
+        </p:nvSpPr>
+        <p:spPr>
+          <a:xfrm>
+            <a:off x="4983480" y="1435608"/>
+            <a:ext cx="3611880" cy="411480"/>
           </a:xfrm>
           <a:prstGeom prst="rect">
             <a:avLst/>
@@ -3605,84 +3338,55 @@
           <a:lstStyle/>
           <a:p>
             <a:pPr indent="0" marL="0">
-              <a:spcAft>
-                <a:spcPts val="300"/>
-              </a:spcAft>
               <a:buNone/>
             </a:pPr>
             <a:r>
-              <a:rPr lang="en-US" sz="1300" b="1" dirty="0">
-                <a:solidFill>
-                  <a:schemeClr val="accent4"/>
+              <a:rPr lang="en-US" sz="1100" dirty="0">
+                <a:solidFill>
+                  <a:schemeClr val="tx1"/>
                 </a:solidFill>
               </a:rPr>
-              <a:t>Lo que ganamos</a:t>
+              <a:t>por pauta cubren los US$24K (revenue promedio por cliente 2026: US$5.123). En 2026 fue 1.</a:t>
             </a:r>
-            <a:endParaRPr lang="en-US" sz="1150" dirty="0"/>
-          </a:p>
-          <a:p>
-            <a:pPr indent="0" marL="0">
-              <a:spcAft>
-                <a:spcPts val="300"/>
-              </a:spcAft>
-              <a:buNone/>
-            </a:pPr>
-            <a:r>
-              <a:rPr lang="en-US" sz="1150" dirty="0">
-                <a:solidFill>
-                  <a:schemeClr val="tx1"/>
-                </a:solidFill>
-              </a:rPr>
-              <a:t>Clientes de quien aún no nos conoce: forwarders, brokers y exportadores mexicanos.</a:t>
-            </a:r>
-            <a:endParaRPr lang="en-US" sz="1150" dirty="0"/>
-          </a:p>
-          <a:p>
-            <a:pPr indent="0" marL="0">
-              <a:spcAft>
-                <a:spcPts val="300"/>
-              </a:spcAft>
-              <a:buNone/>
-            </a:pPr>
-            <a:r>
-              <a:rPr lang="en-US" sz="1300" b="1" dirty="0">
-                <a:solidFill>
-                  <a:schemeClr val="accent5"/>
-                </a:solidFill>
-              </a:rPr>
-              <a:t>Lo que perdemos si no lo hacemos</a:t>
-            </a:r>
-            <a:endParaRPr lang="en-US" sz="1150" dirty="0"/>
-          </a:p>
-          <a:p>
-            <a:pPr indent="0" marL="0">
-              <a:spcAft>
-                <a:spcPts val="300"/>
-              </a:spcAft>
-              <a:buNone/>
-            </a:pPr>
-            <a:r>
-              <a:rPr lang="en-US" sz="1150" dirty="0">
-                <a:solidFill>
-                  <a:schemeClr val="tx1"/>
-                </a:solidFill>
-              </a:rPr>
-              <a:t>Seguimos dependiendo de la marca y los referidos, mientras Warp, Go Freight y ExFreight son la respuesta por defecto en Google y en la IA.</a:t>
-            </a:r>
-            <a:endParaRPr lang="en-US" sz="1150" dirty="0"/>
+            <a:endParaRPr lang="en-US" sz="1100" dirty="0"/>
           </a:p>
         </p:txBody>
       </p:sp>
       <p:sp>
         <p:nvSpPr>
-          <p:cNvPr id="6" name="kpi-num-1"/>
+          <p:cNvPr id="7" name="be-card-2"/>
+          <p:cNvSpPr/>
+          <p:nvPr/>
+        </p:nvSpPr>
+        <p:spPr>
+          <a:xfrm>
+            <a:off x="4846320" y="1965960"/>
+            <a:ext cx="3840480" cy="868680"/>
+          </a:xfrm>
+          <a:prstGeom prst="rect">
+            <a:avLst/>
+          </a:prstGeom>
+          <a:solidFill>
+            <a:schemeClr val="bg2"/>
+          </a:solidFill>
+          <a:ln w="12700">
+            <a:solidFill>
+              <a:schemeClr val="bg2"/>
+            </a:solidFill>
+            <a:prstDash val="solid"/>
+          </a:ln>
+        </p:spPr>
+      </p:sp>
+      <p:sp>
+        <p:nvSpPr>
+          <p:cNvPr id="8" name="be-num-2"/>
           <p:cNvSpPr txBox="1"/>
           <p:nvPr/>
         </p:nvSpPr>
         <p:spPr>
           <a:xfrm>
-            <a:off x="4846320" y="2971800"/>
-            <a:ext cx="1828800" cy="411480"/>
+            <a:off x="4983480" y="2029968"/>
+            <a:ext cx="3566160" cy="365760"/>
           </a:xfrm>
           <a:prstGeom prst="rect">
             <a:avLst/>
@@ -3698,7 +3402,7 @@
               <a:buNone/>
             </a:pPr>
             <a:r>
-              <a:rPr lang="en-US" sz="2200" b="1" dirty="0">
+              <a:rPr lang="en-US" sz="2000" b="1" dirty="0">
                 <a:solidFill>
                   <a:schemeClr val="accent1"/>
                 </a:solidFill>
@@ -3706,22 +3410,22 @@
                 <a:ea typeface="Cambria" pitchFamily="34" charset="-122"/>
                 <a:cs typeface="Cambria" pitchFamily="34" charset="-120"/>
               </a:rPr>
-              <a:t>~30</a:t>
+              <a:t>+3 clientes</a:t>
             </a:r>
-            <a:endParaRPr lang="en-US" sz="2200" dirty="0"/>
+            <a:endParaRPr lang="en-US" sz="2000" dirty="0"/>
           </a:p>
         </p:txBody>
       </p:sp>
       <p:sp>
         <p:nvSpPr>
-          <p:cNvPr id="7" name="kpi-label-1"/>
+          <p:cNvPr id="9" name="be-label-2"/>
           <p:cNvSpPr txBox="1"/>
           <p:nvPr/>
         </p:nvSpPr>
         <p:spPr>
           <a:xfrm>
-            <a:off x="4846320" y="3383280"/>
-            <a:ext cx="1828800" cy="365760"/>
+            <a:off x="4983480" y="2395728"/>
+            <a:ext cx="3611880" cy="411480"/>
           </a:xfrm>
           <a:prstGeom prst="rect">
             <a:avLst/>
@@ -3742,7 +3446,7 @@
                   <a:schemeClr val="tx1"/>
                 </a:solidFill>
               </a:rPr>
-              <a:t>clientes nuevos (2026: 19)</a:t>
+              <a:t>orgánicos cubren la agencia (≈US$11,25K ÷ US$4.611 por cliente). De 18 a 21: +17%.</a:t>
             </a:r>
             <a:endParaRPr lang="en-US" sz="1100" dirty="0"/>
           </a:p>
@@ -3750,53 +3454,14 @@
       </p:sp>
       <p:sp>
         <p:nvSpPr>
-          <p:cNvPr id="8" name="kpi-num-2"/>
+          <p:cNvPr id="10" name="text-lose"/>
           <p:cNvSpPr txBox="1"/>
           <p:nvPr/>
         </p:nvSpPr>
         <p:spPr>
           <a:xfrm>
-            <a:off x="6812280" y="2971800"/>
-            <a:ext cx="1828800" cy="411480"/>
-          </a:xfrm>
-          <a:prstGeom prst="rect">
-            <a:avLst/>
-          </a:prstGeom>
-          <a:noFill/>
-          <a:ln/>
-        </p:spPr>
-        <p:txBody>
-          <a:bodyPr wrap="square" lIns="0" tIns="0" rIns="0" bIns="0" rtlCol="0" anchor="ctr"/>
-          <a:lstStyle/>
-          <a:p>
-            <a:pPr indent="0" marL="0">
-              <a:buNone/>
-            </a:pPr>
-            <a:r>
-              <a:rPr lang="en-US" sz="2200" b="1" dirty="0">
-                <a:solidFill>
-                  <a:schemeClr val="accent1"/>
-                </a:solidFill>
-                <a:latin typeface="Cambria" pitchFamily="34" charset="0"/>
-                <a:ea typeface="Cambria" pitchFamily="34" charset="-122"/>
-                <a:cs typeface="Cambria" pitchFamily="34" charset="-120"/>
-              </a:rPr>
-              <a:t>≤US$5K</a:t>
-            </a:r>
-            <a:endParaRPr lang="en-US" sz="2200" dirty="0"/>
-          </a:p>
-        </p:txBody>
-      </p:sp>
-      <p:sp>
-        <p:nvSpPr>
-          <p:cNvPr id="9" name="kpi-label-2"/>
-          <p:cNvSpPr txBox="1"/>
-          <p:nvPr/>
-        </p:nvSpPr>
-        <p:spPr>
-          <a:xfrm>
-            <a:off x="6812280" y="3383280"/>
-            <a:ext cx="1828800" cy="365760"/>
+            <a:off x="4846320" y="3017520"/>
+            <a:ext cx="3840480" cy="685800"/>
           </a:xfrm>
           <a:prstGeom prst="rect">
             <a:avLst/>
@@ -3812,66 +3477,38 @@
               <a:buNone/>
             </a:pPr>
             <a:r>
-              <a:rPr lang="en-US" sz="1100" dirty="0">
-                <a:solidFill>
-                  <a:schemeClr val="tx1"/>
+              <a:rPr lang="en-US" sz="1150" b="1" dirty="0">
+                <a:solidFill>
+                  <a:schemeClr val="accent5"/>
                 </a:solidFill>
               </a:rPr>
-              <a:t>costo por cliente en pauta</a:t>
+              <a:t>Si no lo hacemos: </a:t>
             </a:r>
-            <a:endParaRPr lang="en-US" sz="1100" dirty="0"/>
-          </a:p>
-        </p:txBody>
-      </p:sp>
-      <p:sp>
-        <p:nvSpPr>
-          <p:cNvPr id="10" name="kpi-num-3"/>
-          <p:cNvSpPr txBox="1"/>
-          <p:nvPr/>
-        </p:nvSpPr>
-        <p:spPr>
-          <a:xfrm>
-            <a:off x="4846320" y="3840480"/>
-            <a:ext cx="1828800" cy="411480"/>
-          </a:xfrm>
-          <a:prstGeom prst="rect">
-            <a:avLst/>
-          </a:prstGeom>
-          <a:noFill/>
-          <a:ln/>
-        </p:spPr>
-        <p:txBody>
-          <a:bodyPr wrap="square" lIns="0" tIns="0" rIns="0" bIns="0" rtlCol="0" anchor="ctr"/>
-          <a:lstStyle/>
-          <a:p>
             <a:pPr indent="0" marL="0">
               <a:buNone/>
             </a:pPr>
             <a:r>
-              <a:rPr lang="en-US" sz="2200" b="1" dirty="0">
-                <a:solidFill>
-                  <a:schemeClr val="accent1"/>
-                </a:solidFill>
-                <a:latin typeface="Cambria" pitchFamily="34" charset="0"/>
-                <a:ea typeface="Cambria" pitchFamily="34" charset="-122"/>
-                <a:cs typeface="Cambria" pitchFamily="34" charset="-120"/>
+              <a:rPr lang="en-US" sz="1150" dirty="0">
+                <a:solidFill>
+                  <a:schemeClr val="tx1"/>
+                </a:solidFill>
               </a:rPr>
-              <a:t>≥40%</a:t>
+              <a:t>seguimos dependiendo de la marca y los referidos, mientras Warp, Go Freight y ExFreight son la respuesta por defecto en Google y en la IA.</a:t>
             </a:r>
-            <a:endParaRPr lang="en-US" sz="2200" dirty="0"/>
+            <a:endParaRPr lang="en-US" sz="1150" dirty="0"/>
           </a:p>
         </p:txBody>
       </p:sp>
       <p:sp>
         <p:nvSpPr>
-          <p:cNvPr id="11" name="kpi-label-3"/>
+          <p:cNvPr id="11" name="text-kpis"/>
           <p:cNvSpPr txBox="1"/>
           <p:nvPr/>
         </p:nvSpPr>
         <p:spPr>
           <a:xfrm>
-            <a:off x="4846320" y="4251960"/>
-            <a:ext cx="1828800" cy="365760"/>
+            <a:off x="4846320" y="3794760"/>
+            <a:ext cx="3840480" cy="822960"/>
           </a:xfrm>
           <a:prstGeom prst="rect">
             <a:avLst/>
@@ -3887,89 +3524,25 @@
               <a:buNone/>
             </a:pPr>
             <a:r>
-              <a:rPr lang="en-US" sz="1100" dirty="0">
-                <a:solidFill>
-                  <a:schemeClr val="tx1"/>
+              <a:rPr lang="en-US" sz="1150" b="1" dirty="0">
+                <a:solidFill>
+                  <a:schemeClr val="accent4"/>
                 </a:solidFill>
               </a:rPr>
-              <a:t>tráfico orgánico sin marca</a:t>
+              <a:t>Metas que proponemos: </a:t>
             </a:r>
-            <a:endParaRPr lang="en-US" sz="1100" dirty="0"/>
-          </a:p>
-        </p:txBody>
-      </p:sp>
-      <p:sp>
-        <p:nvSpPr>
-          <p:cNvPr id="12" name="kpi-num-4"/>
-          <p:cNvSpPr txBox="1"/>
-          <p:nvPr/>
-        </p:nvSpPr>
-        <p:spPr>
-          <a:xfrm>
-            <a:off x="6812280" y="3840480"/>
-            <a:ext cx="1828800" cy="411480"/>
-          </a:xfrm>
-          <a:prstGeom prst="rect">
-            <a:avLst/>
-          </a:prstGeom>
-          <a:noFill/>
-          <a:ln/>
-        </p:spPr>
-        <p:txBody>
-          <a:bodyPr wrap="square" lIns="0" tIns="0" rIns="0" bIns="0" rtlCol="0" anchor="ctr"/>
-          <a:lstStyle/>
-          <a:p>
             <a:pPr indent="0" marL="0">
               <a:buNone/>
             </a:pPr>
             <a:r>
-              <a:rPr lang="en-US" sz="2200" b="1" dirty="0">
-                <a:solidFill>
-                  <a:schemeClr val="accent1"/>
-                </a:solidFill>
-                <a:latin typeface="Cambria" pitchFamily="34" charset="0"/>
-                <a:ea typeface="Cambria" pitchFamily="34" charset="-122"/>
-                <a:cs typeface="Cambria" pitchFamily="34" charset="-120"/>
+              <a:rPr lang="en-US" sz="1150" dirty="0">
+                <a:solidFill>
+                  <a:schemeClr val="tx1"/>
+                </a:solidFill>
               </a:rPr>
-              <a:t>7 → 70+</a:t>
+              <a:t>costo por cliente en pauta de US$15K a ≤US$5K; calificados que cierran de 5,6% a ≥12%; más tráfico orgánico sin marca y más citas en la IA.</a:t>
             </a:r>
-            <a:endParaRPr lang="en-US" sz="2200" dirty="0"/>
-          </a:p>
-        </p:txBody>
-      </p:sp>
-      <p:sp>
-        <p:nvSpPr>
-          <p:cNvPr id="13" name="kpi-label-4"/>
-          <p:cNvSpPr txBox="1"/>
-          <p:nvPr/>
-        </p:nvSpPr>
-        <p:spPr>
-          <a:xfrm>
-            <a:off x="6812280" y="4251960"/>
-            <a:ext cx="1828800" cy="365760"/>
-          </a:xfrm>
-          <a:prstGeom prst="rect">
-            <a:avLst/>
-          </a:prstGeom>
-          <a:noFill/>
-          <a:ln/>
-        </p:spPr>
-        <p:txBody>
-          <a:bodyPr wrap="square" lIns="0" tIns="0" rIns="0" bIns="0" rtlCol="0" anchor="t"/>
-          <a:lstStyle/>
-          <a:p>
-            <a:pPr indent="0" marL="0">
-              <a:buNone/>
-            </a:pPr>
-            <a:r>
-              <a:rPr lang="en-US" sz="1100" dirty="0">
-                <a:solidFill>
-                  <a:schemeClr val="tx1"/>
-                </a:solidFill>
-              </a:rPr>
-              <a:t>citas en la IA de Google</a:t>
-            </a:r>
-            <a:endParaRPr lang="en-US" sz="1100" dirty="0"/>
+            <a:endParaRPr lang="en-US" sz="1150" dirty="0"/>
           </a:p>
         </p:txBody>
       </p:sp>

</xml_diff>

<commit_message>
Update 2027 pitch with Google/Meta split and agency-managed paid media
Co-Authored-By: Claude Opus 5.5 <noreply@anthropic.com>
Claude-Session: https://claude.ai/code/session_011mVvDzVJqJWuqDhVDGwPKG
</commit_message>
<xml_diff>
--- a/reports/GLT_Budget_Marketing_2027.pptx
+++ b/reports/GLT_Budget_Marketing_2027.pptx
@@ -109,17 +109,17 @@
   <p:extLst>
     <p:ext uri="{521415D9-36F7-43E2-AB2F-B90AF26B5E84}">
       <p14:sectionLst xmlns:p14="http://schemas.microsoft.com/office/powerpoint/2010/main">
-        <p14:section name="Resultados 2026" id="{5ee896c5-15a9-12b5-2e83-81647452863a}">
+        <p14:section name="Resultados 2026" id="{471e41cd-3711-af9a-059d-1695a7716768}">
           <p14:sldIdLst>
             <p14:sldId id="256"/>
           </p14:sldIdLst>
         </p14:section>
-        <p14:section name="Presupuesto 2027" id="{fe2c549a-3a05-48db-8461-9abd57ec6d90}">
+        <p14:section name="Presupuesto 2027" id="{839461ac-67ca-3d83-68dd-6a60b7d4ed51}">
           <p14:sldIdLst>
             <p14:sldId id="257"/>
           </p14:sldIdLst>
         </p14:section>
-        <p14:section name="Metas 2027" id="{4b4e1045-8a47-07b0-c75c-ba56eb8841fe}">
+        <p14:section name="Metas 2027" id="{9b7dd0cf-80e9-5c89-7619-cd6eacf082ee}">
           <p14:sldIdLst>
             <p14:sldId id="258"/>
           </p14:sldIdLst>
@@ -622,7 +622,7 @@
               <c:strCache>
                 <c:ptCount val="1"/>
                 <c:pt idx="0">
-                  <c:v>Agencia SEO, GEO y web (COP 45M ≈ US$11,25K)</c:v>
+                  <c:v>Agencia: SEO, GEO, web y gestión de pauta (COP 45M ≈ US$11,25K)</c:v>
                 </c:pt>
               </c:strCache>
             </c:strRef>
@@ -1590,7 +1590,7 @@
           <a:p>
             <a:r>
               <a:rPr lang="en-US" dirty="0"/>
-              <a:t>Datos 2026 (internos): pauta US$15.000 en Google Search y Meta → 70 leads, 18 calificados, 1 venta de US$14.330. Costo por lead US$214, por lead calificado US$833, por cliente US$15.000; revenue/inversión 0,96x. Orgánico + directo → 186 leads, 90 calificados, 18 clientes, US$83.000. Calidad: 48% de los leads orgánicos califica (pauta 26%) y 20% de los calificados cierra (pauta 5,6%). Matiz: 'orgánico + directo' incluye a quien ya nos conoce; según OpenRush (28 oct 2026), 8 de cada 10 visitas orgánicas buscan 'GLT' por nombre. Con 1 sola venta por pauta la muestra es chica: la conclusión no es que la pauta no sirva, sino que como la hicimos no se pagó.</a:t>
+              <a:t>Datos 2026 (internos): pauta US$15.000 (US$11.000 en Google Search y US$4.000 en Meta) → 70 leads, 18 calificados, 1 venta de US$14.330. Costo por lead US$214, por lead calificado US$833, por cliente US$15.000; revenue/inversión 0,96x. Orgánico + directo → 186 leads, 90 calificados, 18 clientes, US$83.000. Calidad: 48% de los leads orgánicos califica (pauta 26%) y 20% de los calificados cierra (pauta 5,6%). Matiz: 'orgánico + directo' incluye a quien ya nos conoce; según OpenRush (28 oct 2026), 8 de cada 10 visitas orgánicas buscan 'GLT' por nombre. Con 1 sola venta por pauta la muestra es chica: la conclusión no es que la pauta no sirva, sino que como la hicimos no se pagó.</a:t>
             </a:r>
             <a:endParaRPr lang="en-US" dirty="0"/>
           </a:p>
@@ -1678,7 +1678,7 @@
           <a:p>
             <a:r>
               <a:rPr lang="en-US" dirty="0"/>
-              <a:t>Lo que pedimos: US$24.000 de pauta digital de marca GLT (leads y awareness) y COP 45 millones para la agencia digital de SEO, GEO y optimización del sitio. Conversión de referencia: COP 45M ≈ US$11.250 a la TRM de $4.000 usada en la matriz de evaluación de agencias; Finanzas debe ajustarla a la TRM vigente. Total ≈ US$35.250 frente a US$15.000 de pauta en 2026. La pauta sube 60%, pero cambia de enfoque: la de 2026 no se pagó. Por eso Meta sale de la captación en frío, Google se concentra en búsquedas de nicho y en español en México, y hay regla de pausa en el Q2. La agencia invierte en el canal que ya trae el 95% de los clientes, para que también traiga a quien todavía no nos conoce. Por confirmar: si la gestión de la pauta la hace el equipo interno o la agencia, porque las propuestas de agencia cobran esa gestión aparte del adspend.</a:t>
+              <a:t>Lo que pedimos: US$24.000 de pauta digital de marca GLT (leads y awareness) y COP 45 millones para la agencia digital de SEO, GEO y optimización del sitio. Conversión de referencia: COP 45M ≈ US$11.250 a la TRM de $4.000 usada en la matriz de evaluación de agencias; Finanzas debe ajustarla a la TRM vigente. Total ≈ US$35.250 frente a US$15.000 de pauta en 2026. La pauta sube 60%, pero cambia de enfoque: la de 2026 no se pagó. Por eso Meta sale de la captación en frío, Google se concentra en búsquedas de nicho y en español en México, y hay regla de pausa en el Q2. La agencia invierte en el canal que ya trae el 95% de los clientes, para que también traiga a quien todavía no nos conoce. La pauta la gestiona la agencia y su fee ya está dentro de los COP 45M: los US$24K van completos a medios.</a:t>
             </a:r>
             <a:endParaRPr lang="en-US" dirty="0"/>
           </a:p>
@@ -1766,7 +1766,7 @@
           <a:p>
             <a:r>
               <a:rPr lang="en-US" dirty="0"/>
-              <a:t>Punto de equilibrio con datos de 2026 (sobre revenue, no sobre margen). Pauta: US$24.000 ÷ US$5.123 de revenue promedio por cliente (US$97.330 ÷ 19) ≈ 4,7 → 5 clientes; en 2026 fue 1. Para lograrlo con un volumen de leads similar hay que mejorar la calidad: más leads calificados y más cierre, por eso cambia la segmentación. Agencia: ≈US$11.250 ÷ US$4.611 de revenue promedio por cliente orgánico (US$83.000 ÷ 18) ≈ 2,4 → 3 clientes más, de 18 a 21; al 9,7% de conversión de lead a cliente orgánico de 2026, son unos 31 leads orgánicos más. El revenue no es margen: Finanzas debe validar margen bruto y recompra. Las metas son propuestas de seguimiento, no promesas.</a:t>
+              <a:t>Punto de equilibrio con datos de 2026 (sobre revenue, no sobre margen). Pauta: US$24.000 ÷ US$5.123 de revenue promedio por cliente (US$97.330 ÷ 19) ≈ 4,7 → 5 clientes; en 2026 fue 1. Para lograrlo con un volumen de leads similar hay que mejorar la calidad: más leads calificados y más cierre, por eso cambia la segmentación. Agencia: ≈US$11.250 ÷ US$4.611 de revenue promedio por cliente orgánico (US$83.000 ÷ 18) ≈ 2,4 → 3 clientes más, de 18 a 21; al 9,7% de conversión de lead a cliente orgánico de 2026, son unos 31 leads orgánicos más. En conjunto, ≈US$35.250 ÷ US$5.123 ≈ 7 clientes atribuibles cubren todo el programa. El equilibrio es sobre revenue porque GLT aún no tiene definidos margen bruto ni recompra por cliente; definirlos con Finanzas es una tarea de 2027. Las metas son propuestas de seguimiento, no promesas.</a:t>
             </a:r>
             <a:endParaRPr lang="en-US" dirty="0"/>
           </a:p>
@@ -2656,7 +2656,7 @@
                   <a:schemeClr val="tx1"/>
                 </a:solidFill>
               </a:rPr>
-              <a:t>costó el único cliente que trajo la pauta (US$14.330 de revenue; 0,96x lo invertido)</a:t>
+              <a:t>costó el único cliente de la pauta: US$11K en Google y US$4K en Meta, con revenue de 0,96x</a:t>
             </a:r>
             <a:endParaRPr lang="en-US" sz="1150" dirty="0"/>
           </a:p>
@@ -2983,7 +2983,7 @@
                   <a:schemeClr val="tx1"/>
                 </a:solidFill>
               </a:rPr>
-              <a:t>Meta sale de la captación en frío; queda para remarketing y awareness.</a:t>
+              <a:t>Meta (US$4K en 2026) sale de la captación en frío; queda para remarketing y awareness.</a:t>
             </a:r>
             <a:endParaRPr lang="en-US" sz="1100" dirty="0"/>
           </a:p>
@@ -3120,6 +3120,24 @@
                 </a:solidFill>
               </a:rPr>
               <a:t>Optimización web: convertir mejor el tráfico que ya trae 95% de los clientes.</a:t>
+            </a:r>
+            <a:endParaRPr lang="en-US" sz="1100" dirty="0"/>
+          </a:p>
+          <a:p>
+            <a:pPr marL="342900" indent="-342900">
+              <a:spcAft>
+                <a:spcPts val="200"/>
+              </a:spcAft>
+              <a:buSzPct val="100000"/>
+              <a:buChar char="•"/>
+            </a:pPr>
+            <a:r>
+              <a:rPr lang="en-US" sz="1100" b="1" dirty="0">
+                <a:solidFill>
+                  <a:schemeClr val="tx1"/>
+                </a:solidFill>
+              </a:rPr>
+              <a:t>Incluye la gestión de los US$24K de pauta.</a:t>
             </a:r>
             <a:endParaRPr lang="en-US" sz="1100" dirty="0"/>
           </a:p>
@@ -3540,7 +3558,7 @@
                   <a:schemeClr val="tx1"/>
                 </a:solidFill>
               </a:rPr>
-              <a:t>costo por cliente en pauta de US$15K a ≤US$5K; calificados que cierran de 5,6% a ≥12%; más tráfico orgánico sin marca y más citas en la IA.</a:t>
+              <a:t>costo por cliente en pauta de US$15K a ≤US$5K y cierre de calificados de 5,6% a ≥12%. En 2027 definimos margen y recompra con Finanzas.</a:t>
             </a:r>
             <a:endParaRPr lang="en-US" sz="1150" dirty="0"/>
           </a:p>

</xml_diff>